<commit_message>
informe: actualizar la presentacion AeroTrack
Co-Authored-By: Claude Sonnet 5.5 <noreply@anthropic.com>
</commit_message>
<xml_diff>
--- a/informe/AeroTrack_Presentacion.pptx
+++ b/informe/AeroTrack_Presentacion.pptx
@@ -5,19 +5,17 @@
     <p:sldMasterId id="2147483648" r:id="rId1"/>
   </p:sldMasterIdLst>
   <p:notesMasterIdLst>
-    <p:notesMasterId r:id="rId12"/>
+    <p:notesMasterId r:id="rId10"/>
   </p:notesMasterIdLst>
   <p:sldIdLst>
     <p:sldId id="256" r:id="rId2"/>
     <p:sldId id="257" r:id="rId3"/>
     <p:sldId id="258" r:id="rId4"/>
     <p:sldId id="259" r:id="rId5"/>
-    <p:sldId id="260" r:id="rId6"/>
-    <p:sldId id="261" r:id="rId7"/>
-    <p:sldId id="264" r:id="rId8"/>
-    <p:sldId id="265" r:id="rId9"/>
-    <p:sldId id="266" r:id="rId10"/>
-    <p:sldId id="268" r:id="rId11"/>
+    <p:sldId id="264" r:id="rId6"/>
+    <p:sldId id="265" r:id="rId7"/>
+    <p:sldId id="266" r:id="rId8"/>
+    <p:sldId id="268" r:id="rId9"/>
   </p:sldIdLst>
   <p:sldSz cx="9144000" cy="5143500" type="screen16x9"/>
   <p:notesSz cx="5143500" cy="9144000"/>
@@ -125,45 +123,70 @@
 <pc:chgInfo xmlns:a="http://schemas.openxmlformats.org/drawingml/2006/main" xmlns:r="http://schemas.openxmlformats.org/officeDocument/2006/relationships" xmlns:ac="http://schemas.microsoft.com/office/drawing/2013/main/command" xmlns:pc="http://schemas.microsoft.com/office/powerpoint/2013/main/command">
   <pc:docChgLst>
     <pc:chgData name="AGUILAR CONTRERAS, Angel Jesus" userId="c4de821b-6fe9-4bab-8aef-481fc69026f7" providerId="ADAL" clId="{BBEC1A91-02B3-44B9-8708-8021BB0904CC}"/>
-    <pc:docChg chg="delSld modSld">
-      <pc:chgData name="AGUILAR CONTRERAS, Angel Jesus" userId="c4de821b-6fe9-4bab-8aef-481fc69026f7" providerId="ADAL" clId="{BBEC1A91-02B3-44B9-8708-8021BB0904CC}" dt="2026-09-30T12:27:46.535" v="3" actId="20577"/>
+    <pc:docChg chg="custSel delSld modSld">
+      <pc:chgData name="AGUILAR CONTRERAS, Angel Jesus" userId="c4de821b-6fe9-4bab-8aef-481fc69026f7" providerId="ADAL" clId="{BBEC1A91-02B3-44B9-8708-8021BB0904CC}" dt="2026-10-07T04:49:11.084" v="28" actId="47"/>
       <pc:docMkLst>
         <pc:docMk/>
       </pc:docMkLst>
-      <pc:sldChg chg="modSp mod">
-        <pc:chgData name="AGUILAR CONTRERAS, Angel Jesus" userId="c4de821b-6fe9-4bab-8aef-481fc69026f7" providerId="ADAL" clId="{BBEC1A91-02B3-44B9-8708-8021BB0904CC}" dt="2026-09-30T12:27:46.535" v="3" actId="20577"/>
+      <pc:sldChg chg="delSp modSp mod">
+        <pc:chgData name="AGUILAR CONTRERAS, Angel Jesus" userId="c4de821b-6fe9-4bab-8aef-481fc69026f7" providerId="ADAL" clId="{BBEC1A91-02B3-44B9-8708-8021BB0904CC}" dt="2026-10-07T04:48:15.581" v="26" actId="1076"/>
         <pc:sldMkLst>
           <pc:docMk/>
           <pc:sldMk cId="0" sldId="256"/>
         </pc:sldMkLst>
         <pc:spChg chg="mod">
-          <ac:chgData name="AGUILAR CONTRERAS, Angel Jesus" userId="c4de821b-6fe9-4bab-8aef-481fc69026f7" providerId="ADAL" clId="{BBEC1A91-02B3-44B9-8708-8021BB0904CC}" dt="2026-09-30T12:27:46.535" v="3" actId="20577"/>
+          <ac:chgData name="AGUILAR CONTRERAS, Angel Jesus" userId="c4de821b-6fe9-4bab-8aef-481fc69026f7" providerId="ADAL" clId="{BBEC1A91-02B3-44B9-8708-8021BB0904CC}" dt="2026-10-07T04:47:38.185" v="11" actId="1076"/>
           <ac:spMkLst>
             <pc:docMk/>
             <pc:sldMk cId="0" sldId="256"/>
             <ac:spMk id="3" creationId="{00000000-0000-0000-0000-000000000000}"/>
           </ac:spMkLst>
         </pc:spChg>
+        <pc:spChg chg="mod">
+          <ac:chgData name="AGUILAR CONTRERAS, Angel Jesus" userId="c4de821b-6fe9-4bab-8aef-481fc69026f7" providerId="ADAL" clId="{BBEC1A91-02B3-44B9-8708-8021BB0904CC}" dt="2026-10-07T04:47:22.058" v="5" actId="20577"/>
+          <ac:spMkLst>
+            <pc:docMk/>
+            <pc:sldMk cId="0" sldId="256"/>
+            <ac:spMk id="4" creationId="{00000000-0000-0000-0000-000000000000}"/>
+          </ac:spMkLst>
+        </pc:spChg>
+        <pc:spChg chg="del">
+          <ac:chgData name="AGUILAR CONTRERAS, Angel Jesus" userId="c4de821b-6fe9-4bab-8aef-481fc69026f7" providerId="ADAL" clId="{BBEC1A91-02B3-44B9-8708-8021BB0904CC}" dt="2026-10-07T04:47:44.108" v="12" actId="478"/>
+          <ac:spMkLst>
+            <pc:docMk/>
+            <pc:sldMk cId="0" sldId="256"/>
+            <ac:spMk id="5" creationId="{00000000-0000-0000-0000-000000000000}"/>
+          </ac:spMkLst>
+        </pc:spChg>
+        <pc:spChg chg="mod">
+          <ac:chgData name="AGUILAR CONTRERAS, Angel Jesus" userId="c4de821b-6fe9-4bab-8aef-481fc69026f7" providerId="ADAL" clId="{BBEC1A91-02B3-44B9-8708-8021BB0904CC}" dt="2026-10-07T04:48:15.581" v="26" actId="1076"/>
+          <ac:spMkLst>
+            <pc:docMk/>
+            <pc:sldMk cId="0" sldId="256"/>
+            <ac:spMk id="6" creationId="{00000000-0000-0000-0000-000000000000}"/>
+          </ac:spMkLst>
+        </pc:spChg>
+        <pc:picChg chg="mod">
+          <ac:chgData name="AGUILAR CONTRERAS, Angel Jesus" userId="c4de821b-6fe9-4bab-8aef-481fc69026f7" providerId="ADAL" clId="{BBEC1A91-02B3-44B9-8708-8021BB0904CC}" dt="2026-10-07T04:47:36.169" v="10" actId="1076"/>
+          <ac:picMkLst>
+            <pc:docMk/>
+            <pc:sldMk cId="0" sldId="256"/>
+            <ac:picMk id="2" creationId="{00000000-0000-0000-0000-000000000000}"/>
+          </ac:picMkLst>
+        </pc:picChg>
       </pc:sldChg>
       <pc:sldChg chg="del">
-        <pc:chgData name="AGUILAR CONTRERAS, Angel Jesus" userId="c4de821b-6fe9-4bab-8aef-481fc69026f7" providerId="ADAL" clId="{BBEC1A91-02B3-44B9-8708-8021BB0904CC}" dt="2026-09-30T12:26:19.559" v="1" actId="47"/>
+        <pc:chgData name="AGUILAR CONTRERAS, Angel Jesus" userId="c4de821b-6fe9-4bab-8aef-481fc69026f7" providerId="ADAL" clId="{BBEC1A91-02B3-44B9-8708-8021BB0904CC}" dt="2026-10-07T04:49:01.579" v="27" actId="47"/>
         <pc:sldMkLst>
           <pc:docMk/>
-          <pc:sldMk cId="0" sldId="262"/>
+          <pc:sldMk cId="0" sldId="260"/>
         </pc:sldMkLst>
       </pc:sldChg>
       <pc:sldChg chg="del">
-        <pc:chgData name="AGUILAR CONTRERAS, Angel Jesus" userId="c4de821b-6fe9-4bab-8aef-481fc69026f7" providerId="ADAL" clId="{BBEC1A91-02B3-44B9-8708-8021BB0904CC}" dt="2026-09-30T12:26:16.920" v="0" actId="47"/>
+        <pc:chgData name="AGUILAR CONTRERAS, Angel Jesus" userId="c4de821b-6fe9-4bab-8aef-481fc69026f7" providerId="ADAL" clId="{BBEC1A91-02B3-44B9-8708-8021BB0904CC}" dt="2026-10-07T04:49:11.084" v="28" actId="47"/>
         <pc:sldMkLst>
           <pc:docMk/>
-          <pc:sldMk cId="0" sldId="263"/>
-        </pc:sldMkLst>
-      </pc:sldChg>
-      <pc:sldChg chg="del">
-        <pc:chgData name="AGUILAR CONTRERAS, Angel Jesus" userId="c4de821b-6fe9-4bab-8aef-481fc69026f7" providerId="ADAL" clId="{BBEC1A91-02B3-44B9-8708-8021BB0904CC}" dt="2026-09-30T12:27:26.056" v="2" actId="47"/>
-        <pc:sldMkLst>
-          <pc:docMk/>
-          <pc:sldMk cId="0" sldId="267"/>
+          <pc:sldMk cId="0" sldId="261"/>
         </pc:sldMkLst>
       </pc:sldChg>
     </pc:docChg>
@@ -654,93 +677,6 @@
 </p:notes>
 </file>
 
-<file path=ppt/notesSlides/notesSlide10.xml><?xml version="1.0" encoding="utf-8"?>
-<p:notes xmlns:a="http://schemas.openxmlformats.org/drawingml/2006/main" xmlns:r="http://schemas.openxmlformats.org/officeDocument/2006/relationships" xmlns:p="http://schemas.openxmlformats.org/presentationml/2006/main">
-  <p:cSld>
-    <p:spTree>
-      <p:nvGrpSpPr>
-        <p:cNvPr id="1" name=""/>
-        <p:cNvGrpSpPr/>
-        <p:nvPr/>
-      </p:nvGrpSpPr>
-      <p:grpSpPr>
-        <a:xfrm>
-          <a:off x="0" y="0"/>
-          <a:ext cx="0" cy="0"/>
-          <a:chOff x="0" y="0"/>
-          <a:chExt cx="0" cy="0"/>
-        </a:xfrm>
-      </p:grpSpPr>
-      <p:sp>
-        <p:nvSpPr>
-          <p:cNvPr id="2" name="Slide Image Placeholder 1"/>
-          <p:cNvSpPr>
-            <a:spLocks noGrp="1" noRot="1" noChangeAspect="1"/>
-          </p:cNvSpPr>
-          <p:nvPr>
-            <p:ph type="sldImg"/>
-          </p:nvPr>
-        </p:nvSpPr>
-        <p:spPr/>
-      </p:sp>
-      <p:sp>
-        <p:nvSpPr>
-          <p:cNvPr id="3" name="Notes Placeholder 2"/>
-          <p:cNvSpPr>
-            <a:spLocks noGrp="1"/>
-          </p:cNvSpPr>
-          <p:nvPr>
-            <p:ph type="body" idx="1"/>
-          </p:nvPr>
-        </p:nvSpPr>
-        <p:spPr/>
-        <p:txBody>
-          <a:bodyPr/>
-          <a:lstStyle/>
-          <a:p>
-            <a:r>
-              <a:rPr lang="en-US" dirty="0"/>
-              <a:t>Cierre y preguntas.</a:t>
-            </a:r>
-          </a:p>
-        </p:txBody>
-      </p:sp>
-      <p:sp>
-        <p:nvSpPr>
-          <p:cNvPr id="4" name="Slide Number Placeholder 3"/>
-          <p:cNvSpPr>
-            <a:spLocks noGrp="1"/>
-          </p:cNvSpPr>
-          <p:nvPr>
-            <p:ph type="sldNum" sz="quarter" idx="10"/>
-          </p:nvPr>
-        </p:nvSpPr>
-        <p:spPr/>
-        <p:txBody>
-          <a:bodyPr/>
-          <a:lstStyle/>
-          <a:p>
-            <a:fld id="{F7021451-1387-4CA6-816F-3879F97B5CBC}" type="slidenum">
-              <a:rPr lang="en-US"/>
-              <a:t>10</a:t>
-            </a:fld>
-            <a:endParaRPr lang="en-US"/>
-          </a:p>
-        </p:txBody>
-      </p:sp>
-    </p:spTree>
-    <p:extLst>
-      <p:ext uri="{BB962C8B-B14F-4D97-AF65-F5344CB8AC3E}">
-        <p14:creationId xmlns:p14="http://schemas.microsoft.com/office/powerpoint/2010/main" val="1024086991"/>
-      </p:ext>
-    </p:extLst>
-  </p:cSld>
-  <p:clrMapOvr>
-    <a:masterClrMapping/>
-  </p:clrMapOvr>
-</p:notes>
-</file>
-
 <file path=ppt/notesSlides/notesSlide2.xml><?xml version="1.0" encoding="utf-8"?>
 <p:notes xmlns:a="http://schemas.openxmlformats.org/drawingml/2006/main" xmlns:r="http://schemas.openxmlformats.org/officeDocument/2006/relationships" xmlns:p="http://schemas.openxmlformats.org/presentationml/2006/main">
   <p:cSld>
@@ -1048,7 +984,7 @@
           <a:p>
             <a:r>
               <a:rPr lang="en-US" dirty="0"/>
-              <a:t>La pantalla Estimacion y pronostico muestra la hora cerrada y la siguiente hora, con el nivel de confianza por negocio.</a:t>
+              <a:t>Es una senal experimental utilizable, no un censo de compradores.</a:t>
             </a:r>
           </a:p>
         </p:txBody>
@@ -1135,7 +1071,7 @@
           <a:p>
             <a:r>
               <a:rPr lang="en-US" dirty="0"/>
-              <a:t>La conversion solo se calcula cuando hay transacciones y entradas medidas en la misma franja.</a:t>
+              <a:t>Modulo AVIE (Adaptive Vision Inference Engine) en following/adaptive.py y detector YOLO en following/detector.py.</a:t>
             </a:r>
           </a:p>
         </p:txBody>
@@ -1222,7 +1158,7 @@
           <a:p>
             <a:r>
               <a:rPr lang="en-US" dirty="0"/>
-              <a:t>Es una senal experimental utilizable, no un censo de compradores.</a:t>
+              <a:t>Cambios en live_core.py, counting/source.py y la pantalla de reportes.</a:t>
             </a:r>
           </a:p>
         </p:txBody>
@@ -1309,7 +1245,7 @@
           <a:p>
             <a:r>
               <a:rPr lang="en-US" dirty="0"/>
-              <a:t>Modulo AVIE (Adaptive Vision Inference Engine) en following/adaptive.py y detector YOLO en following/detector.py.</a:t>
+              <a:t>Cierre y preguntas.</a:t>
             </a:r>
           </a:p>
         </p:txBody>
@@ -1332,93 +1268,6 @@
             <a:fld id="{F7021451-1387-4CA6-816F-3879F97B5CBC}" type="slidenum">
               <a:rPr lang="en-US"/>
               <a:t>8</a:t>
-            </a:fld>
-            <a:endParaRPr lang="en-US"/>
-          </a:p>
-        </p:txBody>
-      </p:sp>
-    </p:spTree>
-    <p:extLst>
-      <p:ext uri="{BB962C8B-B14F-4D97-AF65-F5344CB8AC3E}">
-        <p14:creationId xmlns:p14="http://schemas.microsoft.com/office/powerpoint/2010/main" val="1024086991"/>
-      </p:ext>
-    </p:extLst>
-  </p:cSld>
-  <p:clrMapOvr>
-    <a:masterClrMapping/>
-  </p:clrMapOvr>
-</p:notes>
-</file>
-
-<file path=ppt/notesSlides/notesSlide9.xml><?xml version="1.0" encoding="utf-8"?>
-<p:notes xmlns:a="http://schemas.openxmlformats.org/drawingml/2006/main" xmlns:r="http://schemas.openxmlformats.org/officeDocument/2006/relationships" xmlns:p="http://schemas.openxmlformats.org/presentationml/2006/main">
-  <p:cSld>
-    <p:spTree>
-      <p:nvGrpSpPr>
-        <p:cNvPr id="1" name=""/>
-        <p:cNvGrpSpPr/>
-        <p:nvPr/>
-      </p:nvGrpSpPr>
-      <p:grpSpPr>
-        <a:xfrm>
-          <a:off x="0" y="0"/>
-          <a:ext cx="0" cy="0"/>
-          <a:chOff x="0" y="0"/>
-          <a:chExt cx="0" cy="0"/>
-        </a:xfrm>
-      </p:grpSpPr>
-      <p:sp>
-        <p:nvSpPr>
-          <p:cNvPr id="2" name="Slide Image Placeholder 1"/>
-          <p:cNvSpPr>
-            <a:spLocks noGrp="1" noRot="1" noChangeAspect="1"/>
-          </p:cNvSpPr>
-          <p:nvPr>
-            <p:ph type="sldImg"/>
-          </p:nvPr>
-        </p:nvSpPr>
-        <p:spPr/>
-      </p:sp>
-      <p:sp>
-        <p:nvSpPr>
-          <p:cNvPr id="3" name="Notes Placeholder 2"/>
-          <p:cNvSpPr>
-            <a:spLocks noGrp="1"/>
-          </p:cNvSpPr>
-          <p:nvPr>
-            <p:ph type="body" idx="1"/>
-          </p:nvPr>
-        </p:nvSpPr>
-        <p:spPr/>
-        <p:txBody>
-          <a:bodyPr/>
-          <a:lstStyle/>
-          <a:p>
-            <a:r>
-              <a:rPr lang="en-US" dirty="0"/>
-              <a:t>Cambios en live_core.py, counting/source.py y la pantalla de reportes.</a:t>
-            </a:r>
-          </a:p>
-        </p:txBody>
-      </p:sp>
-      <p:sp>
-        <p:nvSpPr>
-          <p:cNvPr id="4" name="Slide Number Placeholder 3"/>
-          <p:cNvSpPr>
-            <a:spLocks noGrp="1"/>
-          </p:cNvSpPr>
-          <p:nvPr>
-            <p:ph type="sldNum" sz="quarter" idx="10"/>
-          </p:nvPr>
-        </p:nvSpPr>
-        <p:spPr/>
-        <p:txBody>
-          <a:bodyPr/>
-          <a:lstStyle/>
-          <a:p>
-            <a:fld id="{F7021451-1387-4CA6-816F-3879F97B5CBC}" type="slidenum">
-              <a:rPr lang="en-US"/>
-              <a:t>9</a:t>
             </a:fld>
             <a:endParaRPr lang="en-US"/>
           </a:p>
@@ -1789,8 +1638,8 @@
         </p:blipFill>
         <p:spPr>
           <a:xfrm>
-            <a:off x="457200" y="457200"/>
-            <a:ext cx="1005840" cy="1005840"/>
+            <a:off x="3369212" y="181121"/>
+            <a:ext cx="2011680" cy="2011680"/>
           </a:xfrm>
           <a:prstGeom prst="rect">
             <a:avLst/>
@@ -1805,8 +1654,8 @@
         </p:nvSpPr>
         <p:spPr>
           <a:xfrm>
-            <a:off x="457200" y="1691640"/>
-            <a:ext cx="8229600" cy="822960"/>
+            <a:off x="3098409" y="2206869"/>
+            <a:ext cx="2947182" cy="822960"/>
           </a:xfrm>
           <a:prstGeom prst="rect">
             <a:avLst/>
@@ -1860,8 +1709,37 @@
             <a:pPr marL="0" indent="0">
               <a:buNone/>
             </a:pPr>
-            <a:r>
-              <a:rPr lang="en-US" sz="2200" dirty="0">
+            <a:endParaRPr lang="en-US" sz="2200" dirty="0"/>
+          </a:p>
+        </p:txBody>
+      </p:sp>
+      <p:sp>
+        <p:nvSpPr>
+          <p:cNvPr id="6" name="Text 3"/>
+          <p:cNvSpPr txBox="1"/>
+          <p:nvPr/>
+        </p:nvSpPr>
+        <p:spPr>
+          <a:xfrm>
+            <a:off x="3608362" y="3217985"/>
+            <a:ext cx="2138290" cy="1037492"/>
+          </a:xfrm>
+          <a:prstGeom prst="rect">
+            <a:avLst/>
+          </a:prstGeom>
+          <a:noFill/>
+          <a:ln/>
+        </p:spPr>
+        <p:txBody>
+          <a:bodyPr wrap="square" lIns="0" tIns="0" rIns="0" bIns="0" rtlCol="0" anchor="t"/>
+          <a:lstStyle/>
+          <a:p>
+            <a:pPr marL="171450" indent="-171450">
+              <a:buFont typeface="Arial" panose="020B0604020202020204" pitchFamily="34" charset="0"/>
+              <a:buChar char="•"/>
+            </a:pPr>
+            <a:r>
+              <a:rPr lang="en-US" sz="1200" dirty="0">
                 <a:solidFill>
                   <a:srgbClr val="DCE9F5"/>
                 </a:solidFill>
@@ -1869,74 +1747,30 @@
                 <a:ea typeface="Calibri" pitchFamily="34" charset="-122"/>
                 <a:cs typeface="Calibri" pitchFamily="34" charset="-120"/>
               </a:rPr>
-              <a:t>Análisis predictivo de ventas y otras novedades del sistema</a:t>
-            </a:r>
-            <a:endParaRPr lang="en-US" sz="2200" dirty="0"/>
-          </a:p>
-        </p:txBody>
-      </p:sp>
-      <p:sp>
-        <p:nvSpPr>
-          <p:cNvPr id="5" name="Text 2"/>
-          <p:cNvSpPr txBox="1"/>
-          <p:nvPr/>
-        </p:nvSpPr>
-        <p:spPr>
-          <a:xfrm>
-            <a:off x="457200" y="3703320"/>
-            <a:ext cx="8229600" cy="320040"/>
-          </a:xfrm>
-          <a:prstGeom prst="rect">
-            <a:avLst/>
-          </a:prstGeom>
-          <a:noFill/>
-          <a:ln/>
-        </p:spPr>
-        <p:txBody>
-          <a:bodyPr wrap="square" lIns="0" tIns="0" rIns="0" bIns="0" rtlCol="0" anchor="t"/>
-          <a:lstStyle/>
-          <a:p>
-            <a:pPr marL="0" indent="0">
-              <a:buNone/>
-            </a:pPr>
-            <a:r>
-              <a:rPr lang="en-US" sz="1400" b="1" dirty="0">
-                <a:solidFill>
-                  <a:srgbClr val="F2A93B"/>
+              <a:t>Angel Aguilar</a:t>
+            </a:r>
+          </a:p>
+          <a:p>
+            <a:pPr marL="171450" indent="-171450">
+              <a:buFont typeface="Arial" panose="020B0604020202020204" pitchFamily="34" charset="0"/>
+              <a:buChar char="•"/>
+            </a:pPr>
+            <a:r>
+              <a:rPr lang="en-US" sz="1200" dirty="0">
+                <a:solidFill>
+                  <a:srgbClr val="DCE9F5"/>
                 </a:solidFill>
                 <a:latin typeface="Calibri" pitchFamily="34" charset="0"/>
                 <a:ea typeface="Calibri" pitchFamily="34" charset="-122"/>
                 <a:cs typeface="Calibri" pitchFamily="34" charset="-120"/>
               </a:rPr>
-              <a:t>Aeropuerto Internacional Jorge Chávez  |  Lima Airport Partners (LAP)</a:t>
-            </a:r>
-            <a:endParaRPr lang="en-US" sz="1400" dirty="0"/>
-          </a:p>
-        </p:txBody>
-      </p:sp>
-      <p:sp>
-        <p:nvSpPr>
-          <p:cNvPr id="6" name="Text 3"/>
-          <p:cNvSpPr txBox="1"/>
-          <p:nvPr/>
-        </p:nvSpPr>
-        <p:spPr>
-          <a:xfrm>
-            <a:off x="457200" y="4069080"/>
-            <a:ext cx="8229600" cy="320040"/>
-          </a:xfrm>
-          <a:prstGeom prst="rect">
-            <a:avLst/>
-          </a:prstGeom>
-          <a:noFill/>
-          <a:ln/>
-        </p:spPr>
-        <p:txBody>
-          <a:bodyPr wrap="square" lIns="0" tIns="0" rIns="0" bIns="0" rtlCol="0" anchor="t"/>
-          <a:lstStyle/>
-          <a:p>
-            <a:pPr marL="0" indent="0">
-              <a:buNone/>
+              <a:t> Stephano Rivadeneyra</a:t>
+            </a:r>
+          </a:p>
+          <a:p>
+            <a:pPr marL="171450" indent="-171450">
+              <a:buFont typeface="Arial" panose="020B0604020202020204" pitchFamily="34" charset="0"/>
+              <a:buChar char="•"/>
             </a:pPr>
             <a:r>
               <a:rPr lang="en-US" sz="1200" dirty="0">
@@ -1947,350 +1781,26 @@
                 <a:ea typeface="Calibri" pitchFamily="34" charset="-122"/>
                 <a:cs typeface="Calibri" pitchFamily="34" charset="-120"/>
               </a:rPr>
-              <a:t>Capstone I, Universidad ESAN  |  Angel Aguilar, Stephano Rivadeneyra, José Ortega, Fabián Moreno Ugarte</a:t>
-            </a:r>
-            <a:endParaRPr lang="en-US" sz="1200" dirty="0"/>
-          </a:p>
-        </p:txBody>
-      </p:sp>
-    </p:spTree>
-  </p:cSld>
-  <p:clrMapOvr>
-    <a:masterClrMapping/>
-  </p:clrMapOvr>
-</p:sld>
-</file>
-
-<file path=ppt/slides/slide10.xml><?xml version="1.0" encoding="utf-8"?>
-<p:sld xmlns:a="http://schemas.openxmlformats.org/drawingml/2006/main" xmlns:r="http://schemas.openxmlformats.org/officeDocument/2006/relationships" xmlns:p="http://schemas.openxmlformats.org/presentationml/2006/main">
-  <p:cSld name="Slide 13">
-    <p:bg>
-      <p:bgPr>
-        <a:solidFill>
-          <a:srgbClr val="0B1F3A"/>
-        </a:solidFill>
-        <a:effectLst/>
-      </p:bgPr>
-    </p:bg>
-    <p:spTree>
-      <p:nvGrpSpPr>
-        <p:cNvPr id="1" name=""/>
-        <p:cNvGrpSpPr/>
-        <p:nvPr/>
-      </p:nvGrpSpPr>
-      <p:grpSpPr>
-        <a:xfrm>
-          <a:off x="0" y="0"/>
-          <a:ext cx="0" cy="0"/>
-          <a:chOff x="0" y="0"/>
-          <a:chExt cx="0" cy="0"/>
-        </a:xfrm>
-      </p:grpSpPr>
-      <p:sp>
-        <p:nvSpPr>
-          <p:cNvPr id="2" name="Text 0"/>
-          <p:cNvSpPr txBox="1"/>
-          <p:nvPr/>
-        </p:nvSpPr>
-        <p:spPr>
-          <a:xfrm>
-            <a:off x="457200" y="320040"/>
-            <a:ext cx="8229600" cy="640080"/>
-          </a:xfrm>
-          <a:prstGeom prst="rect">
-            <a:avLst/>
-          </a:prstGeom>
-          <a:noFill/>
-          <a:ln/>
-        </p:spPr>
-        <p:txBody>
-          <a:bodyPr wrap="square" lIns="0" tIns="0" rIns="0" bIns="0" rtlCol="0" anchor="ctr"/>
-          <a:lstStyle/>
-          <a:p>
-            <a:pPr marL="0" indent="0">
-              <a:buNone/>
-            </a:pPr>
-            <a:r>
-              <a:rPr lang="en-US" sz="2800" b="1" dirty="0">
-                <a:solidFill>
-                  <a:srgbClr val="FFFFFF"/>
-                </a:solidFill>
-                <a:latin typeface="Cambria" pitchFamily="34" charset="0"/>
-                <a:ea typeface="Cambria" pitchFamily="34" charset="-122"/>
-                <a:cs typeface="Cambria" pitchFamily="34" charset="-120"/>
-              </a:rPr>
-              <a:t>Conclusiones y próximos pasos</a:t>
-            </a:r>
-            <a:endParaRPr lang="en-US" sz="2800" dirty="0"/>
-          </a:p>
-        </p:txBody>
-      </p:sp>
-      <p:sp>
-        <p:nvSpPr>
-          <p:cNvPr id="3" name="Text 1"/>
-          <p:cNvSpPr txBox="1"/>
-          <p:nvPr/>
-        </p:nvSpPr>
-        <p:spPr>
-          <a:xfrm>
-            <a:off x="457200" y="1188720"/>
-            <a:ext cx="3840480" cy="365760"/>
-          </a:xfrm>
-          <a:prstGeom prst="rect">
-            <a:avLst/>
-          </a:prstGeom>
-          <a:noFill/>
-          <a:ln/>
-        </p:spPr>
-        <p:txBody>
-          <a:bodyPr wrap="square" lIns="0" tIns="0" rIns="0" bIns="0" rtlCol="0" anchor="t"/>
-          <a:lstStyle/>
-          <a:p>
-            <a:pPr marL="0" indent="0">
-              <a:buNone/>
-            </a:pPr>
-            <a:r>
-              <a:rPr lang="en-US" sz="2000" b="1" dirty="0">
-                <a:solidFill>
-                  <a:srgbClr val="F2A93B"/>
-                </a:solidFill>
-                <a:latin typeface="Cambria" pitchFamily="34" charset="0"/>
-                <a:ea typeface="Cambria" pitchFamily="34" charset="-122"/>
-                <a:cs typeface="Cambria" pitchFamily="34" charset="-120"/>
-              </a:rPr>
-              <a:t>Conclusiones</a:t>
-            </a:r>
-            <a:endParaRPr lang="en-US" sz="2000" dirty="0"/>
-          </a:p>
-        </p:txBody>
-      </p:sp>
-      <p:sp>
-        <p:nvSpPr>
-          <p:cNvPr id="4" name="Text 2"/>
-          <p:cNvSpPr txBox="1"/>
-          <p:nvPr/>
-        </p:nvSpPr>
-        <p:spPr>
-          <a:xfrm>
-            <a:off x="457200" y="1691640"/>
-            <a:ext cx="3840480" cy="2743200"/>
-          </a:xfrm>
-          <a:prstGeom prst="rect">
-            <a:avLst/>
-          </a:prstGeom>
-          <a:noFill/>
-          <a:ln/>
-        </p:spPr>
-        <p:txBody>
-          <a:bodyPr wrap="square" lIns="0" tIns="0" rIns="0" bIns="0" rtlCol="0" anchor="t"/>
-          <a:lstStyle/>
-          <a:p>
-            <a:pPr marL="342900" indent="-342900">
-              <a:spcAft>
-                <a:spcPts val="600"/>
-              </a:spcAft>
-              <a:buSzPct val="100000"/>
+              <a:t> José Ortega</a:t>
+            </a:r>
+          </a:p>
+          <a:p>
+            <a:pPr marL="171450" indent="-171450">
+              <a:buFont typeface="Arial" panose="020B0604020202020204" pitchFamily="34" charset="0"/>
               <a:buChar char="•"/>
             </a:pPr>
             <a:r>
-              <a:rPr lang="en-US" sz="1600" dirty="0">
-                <a:solidFill>
-                  <a:srgbClr val="FFFFFF"/>
+              <a:rPr lang="en-US" sz="1200" dirty="0">
+                <a:solidFill>
+                  <a:srgbClr val="DCE9F5"/>
                 </a:solidFill>
                 <a:latin typeface="Calibri" pitchFamily="34" charset="0"/>
                 <a:ea typeface="Calibri" pitchFamily="34" charset="-122"/>
                 <a:cs typeface="Calibri" pitchFamily="34" charset="-120"/>
               </a:rPr>
-              <a:t>El sistema ya conecta personas que entran con ventas por hora.</a:t>
-            </a:r>
-            <a:endParaRPr lang="en-US" sz="1600" dirty="0"/>
-          </a:p>
-          <a:p>
-            <a:pPr marL="342900" indent="-342900">
-              <a:spcAft>
-                <a:spcPts val="600"/>
-              </a:spcAft>
-              <a:buSzPct val="100000"/>
-              <a:buChar char="•"/>
-            </a:pPr>
-            <a:r>
-              <a:rPr lang="en-US" sz="1600" dirty="0">
-                <a:solidFill>
-                  <a:srgbClr val="FFFFFF"/>
-                </a:solidFill>
-                <a:latin typeface="Calibri" pitchFamily="34" charset="0"/>
-                <a:ea typeface="Calibri" pitchFamily="34" charset="-122"/>
-                <a:cs typeface="Calibri" pitchFamily="34" charset="-120"/>
-              </a:rPr>
-              <a:t>Proyecta y pronostica con nivel de confianza explícito.</a:t>
-            </a:r>
-            <a:endParaRPr lang="en-US" sz="1600" dirty="0"/>
-          </a:p>
-          <a:p>
-            <a:pPr marL="342900" indent="-342900">
-              <a:spcAft>
-                <a:spcPts val="600"/>
-              </a:spcAft>
-              <a:buSzPct val="100000"/>
-              <a:buChar char="•"/>
-            </a:pPr>
-            <a:r>
-              <a:rPr lang="en-US" sz="1600" dirty="0">
-                <a:solidFill>
-                  <a:srgbClr val="FFFFFF"/>
-                </a:solidFill>
-                <a:latin typeface="Calibri" pitchFamily="34" charset="0"/>
-                <a:ea typeface="Calibri" pitchFamily="34" charset="-122"/>
-                <a:cs typeface="Calibri" pitchFamily="34" charset="-120"/>
-              </a:rPr>
-              <a:t>Declara sus límites: sin causalidad y sin inventar cifras.</a:t>
-            </a:r>
-            <a:endParaRPr lang="en-US" sz="1600" dirty="0"/>
-          </a:p>
-        </p:txBody>
-      </p:sp>
-      <p:sp>
-        <p:nvSpPr>
-          <p:cNvPr id="5" name="Text 3"/>
-          <p:cNvSpPr txBox="1"/>
-          <p:nvPr/>
-        </p:nvSpPr>
-        <p:spPr>
-          <a:xfrm>
-            <a:off x="4754880" y="1188720"/>
-            <a:ext cx="3840480" cy="365760"/>
-          </a:xfrm>
-          <a:prstGeom prst="rect">
-            <a:avLst/>
-          </a:prstGeom>
-          <a:noFill/>
-          <a:ln/>
-        </p:spPr>
-        <p:txBody>
-          <a:bodyPr wrap="square" lIns="0" tIns="0" rIns="0" bIns="0" rtlCol="0" anchor="t"/>
-          <a:lstStyle/>
-          <a:p>
-            <a:pPr marL="0" indent="0">
-              <a:buNone/>
-            </a:pPr>
-            <a:r>
-              <a:rPr lang="en-US" sz="2000" b="1" dirty="0">
-                <a:solidFill>
-                  <a:srgbClr val="F2A93B"/>
-                </a:solidFill>
-                <a:latin typeface="Cambria" pitchFamily="34" charset="0"/>
-                <a:ea typeface="Cambria" pitchFamily="34" charset="-122"/>
-                <a:cs typeface="Cambria" pitchFamily="34" charset="-120"/>
-              </a:rPr>
-              <a:t>Siguiente</a:t>
-            </a:r>
-            <a:endParaRPr lang="en-US" sz="2000" dirty="0"/>
-          </a:p>
-        </p:txBody>
-      </p:sp>
-      <p:sp>
-        <p:nvSpPr>
-          <p:cNvPr id="6" name="Text 4"/>
-          <p:cNvSpPr txBox="1"/>
-          <p:nvPr/>
-        </p:nvSpPr>
-        <p:spPr>
-          <a:xfrm>
-            <a:off x="4754880" y="1691640"/>
-            <a:ext cx="3840480" cy="2743200"/>
-          </a:xfrm>
-          <a:prstGeom prst="rect">
-            <a:avLst/>
-          </a:prstGeom>
-          <a:noFill/>
-          <a:ln/>
-        </p:spPr>
-        <p:txBody>
-          <a:bodyPr wrap="square" lIns="0" tIns="0" rIns="0" bIns="0" rtlCol="0" anchor="t"/>
-          <a:lstStyle/>
-          <a:p>
-            <a:pPr marL="342900" indent="-342900">
-              <a:spcAft>
-                <a:spcPts val="600"/>
-              </a:spcAft>
-              <a:buSzPct val="100000"/>
-              <a:buChar char="•"/>
-            </a:pPr>
-            <a:r>
-              <a:rPr lang="en-US" sz="1600" dirty="0">
-                <a:solidFill>
-                  <a:srgbClr val="FFFFFF"/>
-                </a:solidFill>
-                <a:latin typeface="Calibri" pitchFamily="34" charset="0"/>
-                <a:ea typeface="Calibri" pitchFamily="34" charset="-122"/>
-                <a:cs typeface="Calibri" pitchFamily="34" charset="-120"/>
-              </a:rPr>
-              <a:t>Probar con ventas reales de un local.</a:t>
-            </a:r>
-            <a:endParaRPr lang="en-US" sz="1600" dirty="0"/>
-          </a:p>
-          <a:p>
-            <a:pPr marL="342900" indent="-342900">
-              <a:spcAft>
-                <a:spcPts val="600"/>
-              </a:spcAft>
-              <a:buSzPct val="100000"/>
-              <a:buChar char="•"/>
-            </a:pPr>
-            <a:r>
-              <a:rPr lang="en-US" sz="1600" dirty="0">
-                <a:solidFill>
-                  <a:srgbClr val="FFFFFF"/>
-                </a:solidFill>
-                <a:latin typeface="Calibri" pitchFamily="34" charset="0"/>
-                <a:ea typeface="Calibri" pitchFamily="34" charset="-122"/>
-                <a:cs typeface="Calibri" pitchFamily="34" charset="-120"/>
-              </a:rPr>
-              <a:t>Medir la precisión con videos anotados.</a:t>
-            </a:r>
-            <a:endParaRPr lang="en-US" sz="1600" dirty="0"/>
-          </a:p>
-          <a:p>
-            <a:pPr marL="342900" indent="-342900">
-              <a:spcAft>
-                <a:spcPts val="600"/>
-              </a:spcAft>
-              <a:buSzPct val="100000"/>
-              <a:buChar char="•"/>
-            </a:pPr>
-            <a:r>
-              <a:rPr lang="en-US" sz="1600" dirty="0">
-                <a:solidFill>
-                  <a:srgbClr val="FFFFFF"/>
-                </a:solidFill>
-                <a:latin typeface="Calibri" pitchFamily="34" charset="0"/>
-                <a:ea typeface="Calibri" pitchFamily="34" charset="-122"/>
-                <a:cs typeface="Calibri" pitchFamily="34" charset="-120"/>
-              </a:rPr>
-              <a:t>Solicitar a LAP material del terminal.</a:t>
-            </a:r>
-            <a:endParaRPr lang="en-US" sz="1600" dirty="0"/>
-          </a:p>
-          <a:p>
-            <a:pPr marL="342900" indent="-342900">
-              <a:spcAft>
-                <a:spcPts val="600"/>
-              </a:spcAft>
-              <a:buSzPct val="100000"/>
-              <a:buChar char="•"/>
-            </a:pPr>
-            <a:r>
-              <a:rPr lang="en-US" sz="1600" dirty="0">
-                <a:solidFill>
-                  <a:srgbClr val="FFFFFF"/>
-                </a:solidFill>
-                <a:latin typeface="Calibri" pitchFamily="34" charset="0"/>
-                <a:ea typeface="Calibri" pitchFamily="34" charset="-122"/>
-                <a:cs typeface="Calibri" pitchFamily="34" charset="-120"/>
-              </a:rPr>
-              <a:t>Evaluar GPU para operar casi en tiempo real.</a:t>
-            </a:r>
-            <a:endParaRPr lang="en-US" sz="1600" dirty="0"/>
+              <a:t>Fabián Moreno Ugarte</a:t>
+            </a:r>
+            <a:endParaRPr lang="en-US" sz="1200" dirty="0"/>
           </a:p>
         </p:txBody>
       </p:sp>
@@ -5616,1235 +5126,6 @@
 
 <file path=ppt/slides/slide5.xml><?xml version="1.0" encoding="utf-8"?>
 <p:sld xmlns:a="http://schemas.openxmlformats.org/drawingml/2006/main" xmlns:r="http://schemas.openxmlformats.org/officeDocument/2006/relationships" xmlns:p="http://schemas.openxmlformats.org/presentationml/2006/main">
-  <p:cSld name="Slide 5">
-    <p:bg>
-      <p:bgPr>
-        <a:solidFill>
-          <a:srgbClr val="0B1F3A"/>
-        </a:solidFill>
-        <a:effectLst/>
-      </p:bgPr>
-    </p:bg>
-    <p:spTree>
-      <p:nvGrpSpPr>
-        <p:cNvPr id="1" name=""/>
-        <p:cNvGrpSpPr/>
-        <p:nvPr/>
-      </p:nvGrpSpPr>
-      <p:grpSpPr>
-        <a:xfrm>
-          <a:off x="0" y="0"/>
-          <a:ext cx="0" cy="0"/>
-          <a:chOff x="0" y="0"/>
-          <a:chExt cx="0" cy="0"/>
-        </a:xfrm>
-      </p:grpSpPr>
-      <p:sp>
-        <p:nvSpPr>
-          <p:cNvPr id="2" name="Text 0"/>
-          <p:cNvSpPr txBox="1"/>
-          <p:nvPr/>
-        </p:nvSpPr>
-        <p:spPr>
-          <a:xfrm>
-            <a:off x="457200" y="320040"/>
-            <a:ext cx="8229600" cy="640080"/>
-          </a:xfrm>
-          <a:prstGeom prst="rect">
-            <a:avLst/>
-          </a:prstGeom>
-          <a:noFill/>
-          <a:ln/>
-        </p:spPr>
-        <p:txBody>
-          <a:bodyPr wrap="square" lIns="0" tIns="0" rIns="0" bIns="0" rtlCol="0" anchor="ctr"/>
-          <a:lstStyle/>
-          <a:p>
-            <a:pPr marL="0" indent="0">
-              <a:buNone/>
-            </a:pPr>
-            <a:r>
-              <a:rPr lang="en-US" sz="2800" b="1" dirty="0">
-                <a:solidFill>
-                  <a:srgbClr val="FFFFFF"/>
-                </a:solidFill>
-                <a:latin typeface="Cambria" pitchFamily="34" charset="0"/>
-                <a:ea typeface="Cambria" pitchFamily="34" charset="-122"/>
-                <a:cs typeface="Cambria" pitchFamily="34" charset="-120"/>
-              </a:rPr>
-              <a:t>Pronóstico de la siguiente hora y confianza</a:t>
-            </a:r>
-            <a:endParaRPr lang="en-US" sz="2800" dirty="0"/>
-          </a:p>
-        </p:txBody>
-      </p:sp>
-      <p:sp>
-        <p:nvSpPr>
-          <p:cNvPr id="3" name="Text 1"/>
-          <p:cNvSpPr txBox="1"/>
-          <p:nvPr/>
-        </p:nvSpPr>
-        <p:spPr>
-          <a:xfrm>
-            <a:off x="457200" y="1097280"/>
-            <a:ext cx="8229600" cy="777240"/>
-          </a:xfrm>
-          <a:prstGeom prst="rect">
-            <a:avLst/>
-          </a:prstGeom>
-          <a:noFill/>
-          <a:ln/>
-        </p:spPr>
-        <p:txBody>
-          <a:bodyPr wrap="square" lIns="0" tIns="0" rIns="0" bIns="0" rtlCol="0" anchor="t"/>
-          <a:lstStyle/>
-          <a:p>
-            <a:pPr marL="0" indent="0">
-              <a:buNone/>
-            </a:pPr>
-            <a:r>
-              <a:rPr lang="en-US" sz="1500" dirty="0">
-                <a:solidFill>
-                  <a:srgbClr val="DCE9F5"/>
-                </a:solidFill>
-                <a:latin typeface="Calibri" pitchFamily="34" charset="0"/>
-                <a:ea typeface="Calibri" pitchFamily="34" charset="-122"/>
-                <a:cs typeface="Calibri" pitchFamily="34" charset="-120"/>
-              </a:rPr>
-              <a:t>El sistema estima primero cuántas personas entrarán en la próxima hora y luego cuánto venderían. Usa la mediana de entradas de la misma hora y el mismo día de semana.</a:t>
-            </a:r>
-            <a:endParaRPr lang="en-US" sz="1500" dirty="0"/>
-          </a:p>
-        </p:txBody>
-      </p:sp>
-      <p:sp>
-        <p:nvSpPr>
-          <p:cNvPr id="4" name="Shape 2"/>
-          <p:cNvSpPr/>
-          <p:nvPr/>
-        </p:nvSpPr>
-        <p:spPr>
-          <a:xfrm>
-            <a:off x="457200" y="2103120"/>
-            <a:ext cx="2651760" cy="1828800"/>
-          </a:xfrm>
-          <a:prstGeom prst="roundRect">
-            <a:avLst>
-              <a:gd name="adj" fmla="val 4000"/>
-            </a:avLst>
-          </a:prstGeom>
-          <a:solidFill>
-            <a:srgbClr val="13315A"/>
-          </a:solidFill>
-          <a:ln w="9525">
-            <a:solidFill>
-              <a:srgbClr val="13315A"/>
-            </a:solidFill>
-            <a:prstDash val="solid"/>
-          </a:ln>
-        </p:spPr>
-        <p:txBody>
-          <a:bodyPr/>
-          <a:lstStyle/>
-          <a:p>
-            <a:endParaRPr lang="es-PE"/>
-          </a:p>
-        </p:txBody>
-      </p:sp>
-      <p:sp>
-        <p:nvSpPr>
-          <p:cNvPr id="5" name="Text 3"/>
-          <p:cNvSpPr txBox="1"/>
-          <p:nvPr/>
-        </p:nvSpPr>
-        <p:spPr>
-          <a:xfrm>
-            <a:off x="640080" y="2194560"/>
-            <a:ext cx="2286000" cy="731520"/>
-          </a:xfrm>
-          <a:prstGeom prst="rect">
-            <a:avLst/>
-          </a:prstGeom>
-          <a:noFill/>
-          <a:ln/>
-        </p:spPr>
-        <p:txBody>
-          <a:bodyPr wrap="square" lIns="0" tIns="0" rIns="0" bIns="0" rtlCol="0" anchor="ctr"/>
-          <a:lstStyle/>
-          <a:p>
-            <a:pPr marL="0" indent="0">
-              <a:buNone/>
-            </a:pPr>
-            <a:r>
-              <a:rPr lang="en-US" sz="3400" b="1" dirty="0">
-                <a:solidFill>
-                  <a:srgbClr val="F2A93B"/>
-                </a:solidFill>
-                <a:latin typeface="Cambria" pitchFamily="34" charset="0"/>
-                <a:ea typeface="Cambria" pitchFamily="34" charset="-122"/>
-                <a:cs typeface="Cambria" pitchFamily="34" charset="-120"/>
-              </a:rPr>
-              <a:t>7 o más</a:t>
-            </a:r>
-            <a:endParaRPr lang="en-US" sz="3400" dirty="0"/>
-          </a:p>
-        </p:txBody>
-      </p:sp>
-      <p:sp>
-        <p:nvSpPr>
-          <p:cNvPr id="6" name="Text 4"/>
-          <p:cNvSpPr txBox="1"/>
-          <p:nvPr/>
-        </p:nvSpPr>
-        <p:spPr>
-          <a:xfrm>
-            <a:off x="640080" y="2926080"/>
-            <a:ext cx="2286000" cy="320040"/>
-          </a:xfrm>
-          <a:prstGeom prst="rect">
-            <a:avLst/>
-          </a:prstGeom>
-          <a:noFill/>
-          <a:ln/>
-        </p:spPr>
-        <p:txBody>
-          <a:bodyPr wrap="square" lIns="0" tIns="0" rIns="0" bIns="0" rtlCol="0" anchor="t"/>
-          <a:lstStyle/>
-          <a:p>
-            <a:pPr marL="0" indent="0">
-              <a:buNone/>
-            </a:pPr>
-            <a:r>
-              <a:rPr lang="en-US" sz="1300" dirty="0">
-                <a:solidFill>
-                  <a:srgbClr val="DCE9F5"/>
-                </a:solidFill>
-                <a:latin typeface="Calibri" pitchFamily="34" charset="0"/>
-                <a:ea typeface="Calibri" pitchFamily="34" charset="-122"/>
-                <a:cs typeface="Calibri" pitchFamily="34" charset="-120"/>
-              </a:rPr>
-              <a:t>días de historial</a:t>
-            </a:r>
-            <a:endParaRPr lang="en-US" sz="1300" dirty="0"/>
-          </a:p>
-        </p:txBody>
-      </p:sp>
-      <p:sp>
-        <p:nvSpPr>
-          <p:cNvPr id="7" name="Text 5"/>
-          <p:cNvSpPr txBox="1"/>
-          <p:nvPr/>
-        </p:nvSpPr>
-        <p:spPr>
-          <a:xfrm>
-            <a:off x="640080" y="3337560"/>
-            <a:ext cx="2286000" cy="502920"/>
-          </a:xfrm>
-          <a:prstGeom prst="rect">
-            <a:avLst/>
-          </a:prstGeom>
-          <a:noFill/>
-          <a:ln/>
-        </p:spPr>
-        <p:txBody>
-          <a:bodyPr wrap="square" lIns="0" tIns="0" rIns="0" bIns="0" rtlCol="0" anchor="t"/>
-          <a:lstStyle/>
-          <a:p>
-            <a:pPr marL="0" indent="0">
-              <a:buNone/>
-            </a:pPr>
-            <a:r>
-              <a:rPr lang="en-US" sz="1500" b="1" dirty="0">
-                <a:solidFill>
-                  <a:srgbClr val="FFFFFF"/>
-                </a:solidFill>
-                <a:latin typeface="Calibri" pitchFamily="34" charset="0"/>
-                <a:ea typeface="Calibri" pitchFamily="34" charset="-122"/>
-                <a:cs typeface="Calibri" pitchFamily="34" charset="-120"/>
-              </a:rPr>
-              <a:t>Confianza alta</a:t>
-            </a:r>
-            <a:endParaRPr lang="en-US" sz="1500" dirty="0"/>
-          </a:p>
-        </p:txBody>
-      </p:sp>
-      <p:sp>
-        <p:nvSpPr>
-          <p:cNvPr id="8" name="Shape 6"/>
-          <p:cNvSpPr/>
-          <p:nvPr/>
-        </p:nvSpPr>
-        <p:spPr>
-          <a:xfrm>
-            <a:off x="3246120" y="2103120"/>
-            <a:ext cx="2651760" cy="1828800"/>
-          </a:xfrm>
-          <a:prstGeom prst="roundRect">
-            <a:avLst>
-              <a:gd name="adj" fmla="val 4000"/>
-            </a:avLst>
-          </a:prstGeom>
-          <a:solidFill>
-            <a:srgbClr val="13315A"/>
-          </a:solidFill>
-          <a:ln w="9525">
-            <a:solidFill>
-              <a:srgbClr val="13315A"/>
-            </a:solidFill>
-            <a:prstDash val="solid"/>
-          </a:ln>
-        </p:spPr>
-        <p:txBody>
-          <a:bodyPr/>
-          <a:lstStyle/>
-          <a:p>
-            <a:endParaRPr lang="es-PE"/>
-          </a:p>
-        </p:txBody>
-      </p:sp>
-      <p:sp>
-        <p:nvSpPr>
-          <p:cNvPr id="9" name="Text 7"/>
-          <p:cNvSpPr txBox="1"/>
-          <p:nvPr/>
-        </p:nvSpPr>
-        <p:spPr>
-          <a:xfrm>
-            <a:off x="3429000" y="2194560"/>
-            <a:ext cx="2286000" cy="731520"/>
-          </a:xfrm>
-          <a:prstGeom prst="rect">
-            <a:avLst/>
-          </a:prstGeom>
-          <a:noFill/>
-          <a:ln/>
-        </p:spPr>
-        <p:txBody>
-          <a:bodyPr wrap="square" lIns="0" tIns="0" rIns="0" bIns="0" rtlCol="0" anchor="ctr"/>
-          <a:lstStyle/>
-          <a:p>
-            <a:pPr marL="0" indent="0">
-              <a:buNone/>
-            </a:pPr>
-            <a:r>
-              <a:rPr lang="en-US" sz="3400" b="1" dirty="0">
-                <a:solidFill>
-                  <a:srgbClr val="F6C878"/>
-                </a:solidFill>
-                <a:latin typeface="Cambria" pitchFamily="34" charset="0"/>
-                <a:ea typeface="Cambria" pitchFamily="34" charset="-122"/>
-                <a:cs typeface="Cambria" pitchFamily="34" charset="-120"/>
-              </a:rPr>
-              <a:t>3 a 6</a:t>
-            </a:r>
-            <a:endParaRPr lang="en-US" sz="3400" dirty="0"/>
-          </a:p>
-        </p:txBody>
-      </p:sp>
-      <p:sp>
-        <p:nvSpPr>
-          <p:cNvPr id="10" name="Text 8"/>
-          <p:cNvSpPr txBox="1"/>
-          <p:nvPr/>
-        </p:nvSpPr>
-        <p:spPr>
-          <a:xfrm>
-            <a:off x="3429000" y="2926080"/>
-            <a:ext cx="2286000" cy="320040"/>
-          </a:xfrm>
-          <a:prstGeom prst="rect">
-            <a:avLst/>
-          </a:prstGeom>
-          <a:noFill/>
-          <a:ln/>
-        </p:spPr>
-        <p:txBody>
-          <a:bodyPr wrap="square" lIns="0" tIns="0" rIns="0" bIns="0" rtlCol="0" anchor="t"/>
-          <a:lstStyle/>
-          <a:p>
-            <a:pPr marL="0" indent="0">
-              <a:buNone/>
-            </a:pPr>
-            <a:r>
-              <a:rPr lang="en-US" sz="1300" dirty="0">
-                <a:solidFill>
-                  <a:srgbClr val="DCE9F5"/>
-                </a:solidFill>
-                <a:latin typeface="Calibri" pitchFamily="34" charset="0"/>
-                <a:ea typeface="Calibri" pitchFamily="34" charset="-122"/>
-                <a:cs typeface="Calibri" pitchFamily="34" charset="-120"/>
-              </a:rPr>
-              <a:t>días de historial</a:t>
-            </a:r>
-            <a:endParaRPr lang="en-US" sz="1300" dirty="0"/>
-          </a:p>
-        </p:txBody>
-      </p:sp>
-      <p:sp>
-        <p:nvSpPr>
-          <p:cNvPr id="11" name="Text 9"/>
-          <p:cNvSpPr txBox="1"/>
-          <p:nvPr/>
-        </p:nvSpPr>
-        <p:spPr>
-          <a:xfrm>
-            <a:off x="3429000" y="3337560"/>
-            <a:ext cx="2286000" cy="502920"/>
-          </a:xfrm>
-          <a:prstGeom prst="rect">
-            <a:avLst/>
-          </a:prstGeom>
-          <a:noFill/>
-          <a:ln/>
-        </p:spPr>
-        <p:txBody>
-          <a:bodyPr wrap="square" lIns="0" tIns="0" rIns="0" bIns="0" rtlCol="0" anchor="t"/>
-          <a:lstStyle/>
-          <a:p>
-            <a:pPr marL="0" indent="0">
-              <a:buNone/>
-            </a:pPr>
-            <a:r>
-              <a:rPr lang="en-US" sz="1500" b="1" dirty="0">
-                <a:solidFill>
-                  <a:srgbClr val="FFFFFF"/>
-                </a:solidFill>
-                <a:latin typeface="Calibri" pitchFamily="34" charset="0"/>
-                <a:ea typeface="Calibri" pitchFamily="34" charset="-122"/>
-                <a:cs typeface="Calibri" pitchFamily="34" charset="-120"/>
-              </a:rPr>
-              <a:t>Confianza media</a:t>
-            </a:r>
-            <a:endParaRPr lang="en-US" sz="1500" dirty="0"/>
-          </a:p>
-        </p:txBody>
-      </p:sp>
-      <p:sp>
-        <p:nvSpPr>
-          <p:cNvPr id="12" name="Shape 10"/>
-          <p:cNvSpPr/>
-          <p:nvPr/>
-        </p:nvSpPr>
-        <p:spPr>
-          <a:xfrm>
-            <a:off x="6035040" y="2103120"/>
-            <a:ext cx="2651760" cy="1828800"/>
-          </a:xfrm>
-          <a:prstGeom prst="roundRect">
-            <a:avLst>
-              <a:gd name="adj" fmla="val 4000"/>
-            </a:avLst>
-          </a:prstGeom>
-          <a:solidFill>
-            <a:srgbClr val="13315A"/>
-          </a:solidFill>
-          <a:ln w="9525">
-            <a:solidFill>
-              <a:srgbClr val="13315A"/>
-            </a:solidFill>
-            <a:prstDash val="solid"/>
-          </a:ln>
-        </p:spPr>
-        <p:txBody>
-          <a:bodyPr/>
-          <a:lstStyle/>
-          <a:p>
-            <a:endParaRPr lang="es-PE"/>
-          </a:p>
-        </p:txBody>
-      </p:sp>
-      <p:sp>
-        <p:nvSpPr>
-          <p:cNvPr id="13" name="Text 11"/>
-          <p:cNvSpPr txBox="1"/>
-          <p:nvPr/>
-        </p:nvSpPr>
-        <p:spPr>
-          <a:xfrm>
-            <a:off x="6217920" y="2194560"/>
-            <a:ext cx="2286000" cy="731520"/>
-          </a:xfrm>
-          <a:prstGeom prst="rect">
-            <a:avLst/>
-          </a:prstGeom>
-          <a:noFill/>
-          <a:ln/>
-        </p:spPr>
-        <p:txBody>
-          <a:bodyPr wrap="square" lIns="0" tIns="0" rIns="0" bIns="0" rtlCol="0" anchor="ctr"/>
-          <a:lstStyle/>
-          <a:p>
-            <a:pPr marL="0" indent="0">
-              <a:buNone/>
-            </a:pPr>
-            <a:r>
-              <a:rPr lang="en-US" sz="3400" b="1" dirty="0">
-                <a:solidFill>
-                  <a:srgbClr val="DCE9F5"/>
-                </a:solidFill>
-                <a:latin typeface="Cambria" pitchFamily="34" charset="0"/>
-                <a:ea typeface="Cambria" pitchFamily="34" charset="-122"/>
-                <a:cs typeface="Cambria" pitchFamily="34" charset="-120"/>
-              </a:rPr>
-              <a:t>Menos de 3</a:t>
-            </a:r>
-            <a:endParaRPr lang="en-US" sz="3400" dirty="0"/>
-          </a:p>
-        </p:txBody>
-      </p:sp>
-      <p:sp>
-        <p:nvSpPr>
-          <p:cNvPr id="14" name="Text 12"/>
-          <p:cNvSpPr txBox="1"/>
-          <p:nvPr/>
-        </p:nvSpPr>
-        <p:spPr>
-          <a:xfrm>
-            <a:off x="6217920" y="2926080"/>
-            <a:ext cx="2286000" cy="320040"/>
-          </a:xfrm>
-          <a:prstGeom prst="rect">
-            <a:avLst/>
-          </a:prstGeom>
-          <a:noFill/>
-          <a:ln/>
-        </p:spPr>
-        <p:txBody>
-          <a:bodyPr wrap="square" lIns="0" tIns="0" rIns="0" bIns="0" rtlCol="0" anchor="t"/>
-          <a:lstStyle/>
-          <a:p>
-            <a:pPr marL="0" indent="0">
-              <a:buNone/>
-            </a:pPr>
-            <a:r>
-              <a:rPr lang="en-US" sz="1300" dirty="0">
-                <a:solidFill>
-                  <a:srgbClr val="DCE9F5"/>
-                </a:solidFill>
-                <a:latin typeface="Calibri" pitchFamily="34" charset="0"/>
-                <a:ea typeface="Calibri" pitchFamily="34" charset="-122"/>
-                <a:cs typeface="Calibri" pitchFamily="34" charset="-120"/>
-              </a:rPr>
-              <a:t>días de historial</a:t>
-            </a:r>
-            <a:endParaRPr lang="en-US" sz="1300" dirty="0"/>
-          </a:p>
-        </p:txBody>
-      </p:sp>
-      <p:sp>
-        <p:nvSpPr>
-          <p:cNvPr id="15" name="Text 13"/>
-          <p:cNvSpPr txBox="1"/>
-          <p:nvPr/>
-        </p:nvSpPr>
-        <p:spPr>
-          <a:xfrm>
-            <a:off x="6217920" y="3337560"/>
-            <a:ext cx="2286000" cy="502920"/>
-          </a:xfrm>
-          <a:prstGeom prst="rect">
-            <a:avLst/>
-          </a:prstGeom>
-          <a:noFill/>
-          <a:ln/>
-        </p:spPr>
-        <p:txBody>
-          <a:bodyPr wrap="square" lIns="0" tIns="0" rIns="0" bIns="0" rtlCol="0" anchor="t"/>
-          <a:lstStyle/>
-          <a:p>
-            <a:pPr marL="0" indent="0">
-              <a:buNone/>
-            </a:pPr>
-            <a:r>
-              <a:rPr lang="en-US" sz="1500" b="1" dirty="0">
-                <a:solidFill>
-                  <a:srgbClr val="FFFFFF"/>
-                </a:solidFill>
-                <a:latin typeface="Calibri" pitchFamily="34" charset="0"/>
-                <a:ea typeface="Calibri" pitchFamily="34" charset="-122"/>
-                <a:cs typeface="Calibri" pitchFamily="34" charset="-120"/>
-              </a:rPr>
-              <a:t>Muestra baja, sin estimación</a:t>
-            </a:r>
-            <a:endParaRPr lang="en-US" sz="1500" dirty="0"/>
-          </a:p>
-        </p:txBody>
-      </p:sp>
-      <p:sp>
-        <p:nvSpPr>
-          <p:cNvPr id="16" name="Text 14"/>
-          <p:cNvSpPr txBox="1"/>
-          <p:nvPr/>
-        </p:nvSpPr>
-        <p:spPr>
-          <a:xfrm>
-            <a:off x="457200" y="4206240"/>
-            <a:ext cx="8229600" cy="548640"/>
-          </a:xfrm>
-          <a:prstGeom prst="rect">
-            <a:avLst/>
-          </a:prstGeom>
-          <a:noFill/>
-          <a:ln/>
-        </p:spPr>
-        <p:txBody>
-          <a:bodyPr wrap="square" lIns="0" tIns="0" rIns="0" bIns="0" rtlCol="0" anchor="t"/>
-          <a:lstStyle/>
-          <a:p>
-            <a:pPr marL="0" indent="0">
-              <a:buNone/>
-            </a:pPr>
-            <a:r>
-              <a:rPr lang="en-US" sz="1400" dirty="0">
-                <a:solidFill>
-                  <a:srgbClr val="FFFFFF"/>
-                </a:solidFill>
-                <a:latin typeface="Calibri" pitchFamily="34" charset="0"/>
-                <a:ea typeface="Calibri" pitchFamily="34" charset="-122"/>
-                <a:cs typeface="Calibri" pitchFamily="34" charset="-120"/>
-              </a:rPr>
-              <a:t>Sin historial de tráfico, el sistema no pronostica: prefiere no dar cifra a inventarla.</a:t>
-            </a:r>
-            <a:endParaRPr lang="en-US" sz="1400" dirty="0"/>
-          </a:p>
-        </p:txBody>
-      </p:sp>
-    </p:spTree>
-  </p:cSld>
-  <p:clrMapOvr>
-    <a:masterClrMapping/>
-  </p:clrMapOvr>
-</p:sld>
-</file>
-
-<file path=ppt/slides/slide6.xml><?xml version="1.0" encoding="utf-8"?>
-<p:sld xmlns:a="http://schemas.openxmlformats.org/drawingml/2006/main" xmlns:r="http://schemas.openxmlformats.org/officeDocument/2006/relationships" xmlns:p="http://schemas.openxmlformats.org/presentationml/2006/main">
-  <p:cSld name="Slide 6">
-    <p:bg>
-      <p:bgPr>
-        <a:solidFill>
-          <a:srgbClr val="F4F7FB"/>
-        </a:solidFill>
-        <a:effectLst/>
-      </p:bgPr>
-    </p:bg>
-    <p:spTree>
-      <p:nvGrpSpPr>
-        <p:cNvPr id="1" name=""/>
-        <p:cNvGrpSpPr/>
-        <p:nvPr/>
-      </p:nvGrpSpPr>
-      <p:grpSpPr>
-        <a:xfrm>
-          <a:off x="0" y="0"/>
-          <a:ext cx="0" cy="0"/>
-          <a:chOff x="0" y="0"/>
-          <a:chExt cx="0" cy="0"/>
-        </a:xfrm>
-      </p:grpSpPr>
-      <p:sp>
-        <p:nvSpPr>
-          <p:cNvPr id="2" name="Text 0"/>
-          <p:cNvSpPr txBox="1"/>
-          <p:nvPr/>
-        </p:nvSpPr>
-        <p:spPr>
-          <a:xfrm>
-            <a:off x="457200" y="320040"/>
-            <a:ext cx="8229600" cy="640080"/>
-          </a:xfrm>
-          <a:prstGeom prst="rect">
-            <a:avLst/>
-          </a:prstGeom>
-          <a:noFill/>
-          <a:ln/>
-        </p:spPr>
-        <p:txBody>
-          <a:bodyPr wrap="square" lIns="0" tIns="0" rIns="0" bIns="0" rtlCol="0" anchor="ctr"/>
-          <a:lstStyle/>
-          <a:p>
-            <a:pPr marL="0" indent="0">
-              <a:buNone/>
-            </a:pPr>
-            <a:r>
-              <a:rPr lang="en-US" sz="2800" b="1" dirty="0">
-                <a:solidFill>
-                  <a:srgbClr val="0B1F3A"/>
-                </a:solidFill>
-                <a:latin typeface="Cambria" pitchFamily="34" charset="0"/>
-                <a:ea typeface="Cambria" pitchFamily="34" charset="-122"/>
-                <a:cs typeface="Cambria" pitchFamily="34" charset="-120"/>
-              </a:rPr>
-              <a:t>Indicadores comerciales por negocio y empresa</a:t>
-            </a:r>
-            <a:endParaRPr lang="en-US" sz="2800" dirty="0"/>
-          </a:p>
-        </p:txBody>
-      </p:sp>
-      <p:sp>
-        <p:nvSpPr>
-          <p:cNvPr id="3" name="Shape 1"/>
-          <p:cNvSpPr/>
-          <p:nvPr/>
-        </p:nvSpPr>
-        <p:spPr>
-          <a:xfrm>
-            <a:off x="457200" y="1188720"/>
-            <a:ext cx="1874520" cy="1645920"/>
-          </a:xfrm>
-          <a:prstGeom prst="roundRect">
-            <a:avLst>
-              <a:gd name="adj" fmla="val 4444"/>
-            </a:avLst>
-          </a:prstGeom>
-          <a:solidFill>
-            <a:srgbClr val="FFFFFF"/>
-          </a:solidFill>
-          <a:ln w="9525">
-            <a:solidFill>
-              <a:srgbClr val="D5DEE9"/>
-            </a:solidFill>
-            <a:prstDash val="solid"/>
-          </a:ln>
-        </p:spPr>
-        <p:txBody>
-          <a:bodyPr/>
-          <a:lstStyle/>
-          <a:p>
-            <a:endParaRPr lang="es-PE"/>
-          </a:p>
-        </p:txBody>
-      </p:sp>
-      <p:sp>
-        <p:nvSpPr>
-          <p:cNvPr id="4" name="Text 2"/>
-          <p:cNvSpPr txBox="1"/>
-          <p:nvPr/>
-        </p:nvSpPr>
-        <p:spPr>
-          <a:xfrm>
-            <a:off x="594360" y="1298448"/>
-            <a:ext cx="1645920" cy="365760"/>
-          </a:xfrm>
-          <a:prstGeom prst="rect">
-            <a:avLst/>
-          </a:prstGeom>
-          <a:noFill/>
-          <a:ln/>
-        </p:spPr>
-        <p:txBody>
-          <a:bodyPr wrap="square" lIns="0" tIns="0" rIns="0" bIns="0" rtlCol="0" anchor="t"/>
-          <a:lstStyle/>
-          <a:p>
-            <a:pPr marL="0" indent="0">
-              <a:buNone/>
-            </a:pPr>
-            <a:r>
-              <a:rPr lang="en-US" sz="1800" b="1" dirty="0">
-                <a:solidFill>
-                  <a:srgbClr val="1F5C8B"/>
-                </a:solidFill>
-                <a:latin typeface="Cambria" pitchFamily="34" charset="0"/>
-                <a:ea typeface="Cambria" pitchFamily="34" charset="-122"/>
-                <a:cs typeface="Cambria" pitchFamily="34" charset="-120"/>
-              </a:rPr>
-              <a:t>Entradas</a:t>
-            </a:r>
-            <a:endParaRPr lang="en-US" sz="1800" dirty="0"/>
-          </a:p>
-        </p:txBody>
-      </p:sp>
-      <p:sp>
-        <p:nvSpPr>
-          <p:cNvPr id="5" name="Text 3"/>
-          <p:cNvSpPr txBox="1"/>
-          <p:nvPr/>
-        </p:nvSpPr>
-        <p:spPr>
-          <a:xfrm>
-            <a:off x="594360" y="1755648"/>
-            <a:ext cx="1645920" cy="1005840"/>
-          </a:xfrm>
-          <a:prstGeom prst="rect">
-            <a:avLst/>
-          </a:prstGeom>
-          <a:noFill/>
-          <a:ln/>
-        </p:spPr>
-        <p:txBody>
-          <a:bodyPr wrap="square" lIns="0" tIns="0" rIns="0" bIns="0" rtlCol="0" anchor="t"/>
-          <a:lstStyle/>
-          <a:p>
-            <a:pPr marL="0" indent="0">
-              <a:buNone/>
-            </a:pPr>
-            <a:r>
-              <a:rPr lang="en-US" sz="1300" dirty="0">
-                <a:solidFill>
-                  <a:srgbClr val="1B2430"/>
-                </a:solidFill>
-                <a:latin typeface="Calibri" pitchFamily="34" charset="0"/>
-                <a:ea typeface="Calibri" pitchFamily="34" charset="-122"/>
-                <a:cs typeface="Calibri" pitchFamily="34" charset="-120"/>
-              </a:rPr>
-              <a:t>Personas que cruzan el acceso en la hora</a:t>
-            </a:r>
-            <a:endParaRPr lang="en-US" sz="1300" dirty="0"/>
-          </a:p>
-        </p:txBody>
-      </p:sp>
-      <p:sp>
-        <p:nvSpPr>
-          <p:cNvPr id="6" name="Shape 4"/>
-          <p:cNvSpPr/>
-          <p:nvPr/>
-        </p:nvSpPr>
-        <p:spPr>
-          <a:xfrm>
-            <a:off x="2578608" y="1188720"/>
-            <a:ext cx="1874520" cy="1645920"/>
-          </a:xfrm>
-          <a:prstGeom prst="roundRect">
-            <a:avLst>
-              <a:gd name="adj" fmla="val 4444"/>
-            </a:avLst>
-          </a:prstGeom>
-          <a:solidFill>
-            <a:srgbClr val="FFFFFF"/>
-          </a:solidFill>
-          <a:ln w="9525">
-            <a:solidFill>
-              <a:srgbClr val="D5DEE9"/>
-            </a:solidFill>
-            <a:prstDash val="solid"/>
-          </a:ln>
-        </p:spPr>
-        <p:txBody>
-          <a:bodyPr/>
-          <a:lstStyle/>
-          <a:p>
-            <a:endParaRPr lang="es-PE"/>
-          </a:p>
-        </p:txBody>
-      </p:sp>
-      <p:sp>
-        <p:nvSpPr>
-          <p:cNvPr id="7" name="Text 5"/>
-          <p:cNvSpPr txBox="1"/>
-          <p:nvPr/>
-        </p:nvSpPr>
-        <p:spPr>
-          <a:xfrm>
-            <a:off x="2715768" y="1298448"/>
-            <a:ext cx="1645920" cy="365760"/>
-          </a:xfrm>
-          <a:prstGeom prst="rect">
-            <a:avLst/>
-          </a:prstGeom>
-          <a:noFill/>
-          <a:ln/>
-        </p:spPr>
-        <p:txBody>
-          <a:bodyPr wrap="square" lIns="0" tIns="0" rIns="0" bIns="0" rtlCol="0" anchor="t"/>
-          <a:lstStyle/>
-          <a:p>
-            <a:pPr marL="0" indent="0">
-              <a:buNone/>
-            </a:pPr>
-            <a:r>
-              <a:rPr lang="en-US" sz="1800" b="1" dirty="0">
-                <a:solidFill>
-                  <a:srgbClr val="1F5C8B"/>
-                </a:solidFill>
-                <a:latin typeface="Cambria" pitchFamily="34" charset="0"/>
-                <a:ea typeface="Cambria" pitchFamily="34" charset="-122"/>
-                <a:cs typeface="Cambria" pitchFamily="34" charset="-120"/>
-              </a:rPr>
-              <a:t>Ventas</a:t>
-            </a:r>
-            <a:endParaRPr lang="en-US" sz="1800" dirty="0"/>
-          </a:p>
-        </p:txBody>
-      </p:sp>
-      <p:sp>
-        <p:nvSpPr>
-          <p:cNvPr id="8" name="Text 6"/>
-          <p:cNvSpPr txBox="1"/>
-          <p:nvPr/>
-        </p:nvSpPr>
-        <p:spPr>
-          <a:xfrm>
-            <a:off x="2715768" y="1755648"/>
-            <a:ext cx="1645920" cy="1005840"/>
-          </a:xfrm>
-          <a:prstGeom prst="rect">
-            <a:avLst/>
-          </a:prstGeom>
-          <a:noFill/>
-          <a:ln/>
-        </p:spPr>
-        <p:txBody>
-          <a:bodyPr wrap="square" lIns="0" tIns="0" rIns="0" bIns="0" rtlCol="0" anchor="t"/>
-          <a:lstStyle/>
-          <a:p>
-            <a:pPr marL="0" indent="0">
-              <a:buNone/>
-            </a:pPr>
-            <a:r>
-              <a:rPr lang="en-US" sz="1300" dirty="0">
-                <a:solidFill>
-                  <a:srgbClr val="1B2430"/>
-                </a:solidFill>
-                <a:latin typeface="Calibri" pitchFamily="34" charset="0"/>
-                <a:ea typeface="Calibri" pitchFamily="34" charset="-122"/>
-                <a:cs typeface="Calibri" pitchFamily="34" charset="-120"/>
-              </a:rPr>
-              <a:t>Monto y transacciones del CSV en esa hora</a:t>
-            </a:r>
-            <a:endParaRPr lang="en-US" sz="1300" dirty="0"/>
-          </a:p>
-        </p:txBody>
-      </p:sp>
-      <p:sp>
-        <p:nvSpPr>
-          <p:cNvPr id="9" name="Shape 7"/>
-          <p:cNvSpPr/>
-          <p:nvPr/>
-        </p:nvSpPr>
-        <p:spPr>
-          <a:xfrm>
-            <a:off x="4700016" y="1188720"/>
-            <a:ext cx="1874520" cy="1645920"/>
-          </a:xfrm>
-          <a:prstGeom prst="roundRect">
-            <a:avLst>
-              <a:gd name="adj" fmla="val 4444"/>
-            </a:avLst>
-          </a:prstGeom>
-          <a:solidFill>
-            <a:srgbClr val="FFFFFF"/>
-          </a:solidFill>
-          <a:ln w="9525">
-            <a:solidFill>
-              <a:srgbClr val="D5DEE9"/>
-            </a:solidFill>
-            <a:prstDash val="solid"/>
-          </a:ln>
-        </p:spPr>
-        <p:txBody>
-          <a:bodyPr/>
-          <a:lstStyle/>
-          <a:p>
-            <a:endParaRPr lang="es-PE"/>
-          </a:p>
-        </p:txBody>
-      </p:sp>
-      <p:sp>
-        <p:nvSpPr>
-          <p:cNvPr id="10" name="Text 8"/>
-          <p:cNvSpPr txBox="1"/>
-          <p:nvPr/>
-        </p:nvSpPr>
-        <p:spPr>
-          <a:xfrm>
-            <a:off x="4837176" y="1298448"/>
-            <a:ext cx="1645920" cy="365760"/>
-          </a:xfrm>
-          <a:prstGeom prst="rect">
-            <a:avLst/>
-          </a:prstGeom>
-          <a:noFill/>
-          <a:ln/>
-        </p:spPr>
-        <p:txBody>
-          <a:bodyPr wrap="square" lIns="0" tIns="0" rIns="0" bIns="0" rtlCol="0" anchor="t"/>
-          <a:lstStyle/>
-          <a:p>
-            <a:pPr marL="0" indent="0">
-              <a:buNone/>
-            </a:pPr>
-            <a:r>
-              <a:rPr lang="en-US" sz="1800" b="1" dirty="0">
-                <a:solidFill>
-                  <a:srgbClr val="1F5C8B"/>
-                </a:solidFill>
-                <a:latin typeface="Cambria" pitchFamily="34" charset="0"/>
-                <a:ea typeface="Cambria" pitchFamily="34" charset="-122"/>
-                <a:cs typeface="Cambria" pitchFamily="34" charset="-120"/>
-              </a:rPr>
-              <a:t>Conversión</a:t>
-            </a:r>
-            <a:endParaRPr lang="en-US" sz="1800" dirty="0"/>
-          </a:p>
-        </p:txBody>
-      </p:sp>
-      <p:sp>
-        <p:nvSpPr>
-          <p:cNvPr id="11" name="Text 9"/>
-          <p:cNvSpPr txBox="1"/>
-          <p:nvPr/>
-        </p:nvSpPr>
-        <p:spPr>
-          <a:xfrm>
-            <a:off x="4837176" y="1755648"/>
-            <a:ext cx="1645920" cy="1005840"/>
-          </a:xfrm>
-          <a:prstGeom prst="rect">
-            <a:avLst/>
-          </a:prstGeom>
-          <a:noFill/>
-          <a:ln/>
-        </p:spPr>
-        <p:txBody>
-          <a:bodyPr wrap="square" lIns="0" tIns="0" rIns="0" bIns="0" rtlCol="0" anchor="t"/>
-          <a:lstStyle/>
-          <a:p>
-            <a:pPr marL="0" indent="0">
-              <a:buNone/>
-            </a:pPr>
-            <a:r>
-              <a:rPr lang="en-US" sz="1300" dirty="0">
-                <a:solidFill>
-                  <a:srgbClr val="1B2430"/>
-                </a:solidFill>
-                <a:latin typeface="Calibri" pitchFamily="34" charset="0"/>
-                <a:ea typeface="Calibri" pitchFamily="34" charset="-122"/>
-                <a:cs typeface="Calibri" pitchFamily="34" charset="-120"/>
-              </a:rPr>
-              <a:t>Transacciones entre entradas, en porcentaje</a:t>
-            </a:r>
-            <a:endParaRPr lang="en-US" sz="1300" dirty="0"/>
-          </a:p>
-        </p:txBody>
-      </p:sp>
-      <p:sp>
-        <p:nvSpPr>
-          <p:cNvPr id="12" name="Shape 10"/>
-          <p:cNvSpPr/>
-          <p:nvPr/>
-        </p:nvSpPr>
-        <p:spPr>
-          <a:xfrm>
-            <a:off x="6821424" y="1188720"/>
-            <a:ext cx="1874520" cy="1645920"/>
-          </a:xfrm>
-          <a:prstGeom prst="roundRect">
-            <a:avLst>
-              <a:gd name="adj" fmla="val 4444"/>
-            </a:avLst>
-          </a:prstGeom>
-          <a:solidFill>
-            <a:srgbClr val="FFFFFF"/>
-          </a:solidFill>
-          <a:ln w="9525">
-            <a:solidFill>
-              <a:srgbClr val="D5DEE9"/>
-            </a:solidFill>
-            <a:prstDash val="solid"/>
-          </a:ln>
-        </p:spPr>
-        <p:txBody>
-          <a:bodyPr/>
-          <a:lstStyle/>
-          <a:p>
-            <a:endParaRPr lang="es-PE"/>
-          </a:p>
-        </p:txBody>
-      </p:sp>
-      <p:sp>
-        <p:nvSpPr>
-          <p:cNvPr id="13" name="Text 11"/>
-          <p:cNvSpPr txBox="1"/>
-          <p:nvPr/>
-        </p:nvSpPr>
-        <p:spPr>
-          <a:xfrm>
-            <a:off x="6958584" y="1298448"/>
-            <a:ext cx="1645920" cy="365760"/>
-          </a:xfrm>
-          <a:prstGeom prst="rect">
-            <a:avLst/>
-          </a:prstGeom>
-          <a:noFill/>
-          <a:ln/>
-        </p:spPr>
-        <p:txBody>
-          <a:bodyPr wrap="square" lIns="0" tIns="0" rIns="0" bIns="0" rtlCol="0" anchor="t"/>
-          <a:lstStyle/>
-          <a:p>
-            <a:pPr marL="0" indent="0">
-              <a:buNone/>
-            </a:pPr>
-            <a:r>
-              <a:rPr lang="en-US" sz="1800" b="1" dirty="0">
-                <a:solidFill>
-                  <a:srgbClr val="1F5C8B"/>
-                </a:solidFill>
-                <a:latin typeface="Cambria" pitchFamily="34" charset="0"/>
-                <a:ea typeface="Cambria" pitchFamily="34" charset="-122"/>
-                <a:cs typeface="Cambria" pitchFamily="34" charset="-120"/>
-              </a:rPr>
-              <a:t>Proyección</a:t>
-            </a:r>
-            <a:endParaRPr lang="en-US" sz="1800" dirty="0"/>
-          </a:p>
-        </p:txBody>
-      </p:sp>
-      <p:sp>
-        <p:nvSpPr>
-          <p:cNvPr id="14" name="Text 12"/>
-          <p:cNvSpPr txBox="1"/>
-          <p:nvPr/>
-        </p:nvSpPr>
-        <p:spPr>
-          <a:xfrm>
-            <a:off x="6958584" y="1755648"/>
-            <a:ext cx="1645920" cy="1005840"/>
-          </a:xfrm>
-          <a:prstGeom prst="rect">
-            <a:avLst/>
-          </a:prstGeom>
-          <a:noFill/>
-          <a:ln/>
-        </p:spPr>
-        <p:txBody>
-          <a:bodyPr wrap="square" lIns="0" tIns="0" rIns="0" bIns="0" rtlCol="0" anchor="t"/>
-          <a:lstStyle/>
-          <a:p>
-            <a:pPr marL="0" indent="0">
-              <a:buNone/>
-            </a:pPr>
-            <a:r>
-              <a:rPr lang="en-US" sz="1300" dirty="0">
-                <a:solidFill>
-                  <a:srgbClr val="1B2430"/>
-                </a:solidFill>
-                <a:latin typeface="Calibri" pitchFamily="34" charset="0"/>
-                <a:ea typeface="Calibri" pitchFamily="34" charset="-122"/>
-                <a:cs typeface="Calibri" pitchFamily="34" charset="-120"/>
-              </a:rPr>
-              <a:t>Venta estimada frente a la venta real</a:t>
-            </a:r>
-            <a:endParaRPr lang="en-US" sz="1300" dirty="0"/>
-          </a:p>
-        </p:txBody>
-      </p:sp>
-      <p:sp>
-        <p:nvSpPr>
-          <p:cNvPr id="15" name="Text 13"/>
-          <p:cNvSpPr txBox="1"/>
-          <p:nvPr/>
-        </p:nvSpPr>
-        <p:spPr>
-          <a:xfrm>
-            <a:off x="457200" y="3108960"/>
-            <a:ext cx="8229600" cy="1737360"/>
-          </a:xfrm>
-          <a:prstGeom prst="rect">
-            <a:avLst/>
-          </a:prstGeom>
-          <a:noFill/>
-          <a:ln/>
-        </p:spPr>
-        <p:txBody>
-          <a:bodyPr wrap="square" lIns="0" tIns="0" rIns="0" bIns="0" rtlCol="0" anchor="t"/>
-          <a:lstStyle/>
-          <a:p>
-            <a:pPr marL="342900" indent="-342900">
-              <a:spcAft>
-                <a:spcPts val="600"/>
-              </a:spcAft>
-              <a:buSzPct val="100000"/>
-              <a:buChar char="•"/>
-            </a:pPr>
-            <a:r>
-              <a:rPr lang="en-US" sz="1500" dirty="0">
-                <a:solidFill>
-                  <a:srgbClr val="1B2430"/>
-                </a:solidFill>
-                <a:latin typeface="Calibri" pitchFamily="34" charset="0"/>
-                <a:ea typeface="Calibri" pitchFamily="34" charset="-122"/>
-                <a:cs typeface="Calibri" pitchFamily="34" charset="-120"/>
-              </a:rPr>
-              <a:t>Resumen horario por negocio: entradas, salidas, cobertura, ventas y estimación en cada hora.</a:t>
-            </a:r>
-            <a:endParaRPr lang="en-US" sz="1500" dirty="0"/>
-          </a:p>
-          <a:p>
-            <a:pPr marL="342900" indent="-342900">
-              <a:spcAft>
-                <a:spcPts val="600"/>
-              </a:spcAft>
-              <a:buSzPct val="100000"/>
-              <a:buChar char="•"/>
-            </a:pPr>
-            <a:r>
-              <a:rPr lang="en-US" sz="1500" dirty="0">
-                <a:solidFill>
-                  <a:srgbClr val="1B2430"/>
-                </a:solidFill>
-                <a:latin typeface="Calibri" pitchFamily="34" charset="0"/>
-                <a:ea typeface="Calibri" pitchFamily="34" charset="-122"/>
-                <a:cs typeface="Calibri" pitchFamily="34" charset="-120"/>
-              </a:rPr>
-              <a:t>Vista agrupada por empresa u operador, con totales de entradas, ventas, estimación y conversión.</a:t>
-            </a:r>
-            <a:endParaRPr lang="en-US" sz="1500" dirty="0"/>
-          </a:p>
-          <a:p>
-            <a:pPr marL="342900" indent="-342900">
-              <a:spcAft>
-                <a:spcPts val="600"/>
-              </a:spcAft>
-              <a:buSzPct val="100000"/>
-              <a:buChar char="•"/>
-            </a:pPr>
-            <a:r>
-              <a:rPr lang="en-US" sz="1500" dirty="0">
-                <a:solidFill>
-                  <a:srgbClr val="1B2430"/>
-                </a:solidFill>
-                <a:latin typeface="Calibri" pitchFamily="34" charset="0"/>
-                <a:ea typeface="Calibri" pitchFamily="34" charset="-122"/>
-                <a:cs typeface="Calibri" pitchFamily="34" charset="-120"/>
-              </a:rPr>
-              <a:t>Alertas de planificación sugeridas a partir del pronóstico de la siguiente hora.</a:t>
-            </a:r>
-            <a:endParaRPr lang="en-US" sz="1500" dirty="0"/>
-          </a:p>
-          <a:p>
-            <a:pPr marL="342900" indent="-342900">
-              <a:spcAft>
-                <a:spcPts val="600"/>
-              </a:spcAft>
-              <a:buSzPct val="100000"/>
-              <a:buChar char="•"/>
-            </a:pPr>
-            <a:r>
-              <a:rPr lang="en-US" sz="1500" dirty="0">
-                <a:solidFill>
-                  <a:srgbClr val="1B2430"/>
-                </a:solidFill>
-                <a:latin typeface="Calibri" pitchFamily="34" charset="0"/>
-                <a:ea typeface="Calibri" pitchFamily="34" charset="-122"/>
-                <a:cs typeface="Calibri" pitchFamily="34" charset="-120"/>
-              </a:rPr>
-              <a:t>Cada cifra indica si proviene de datos reales o de prueba.</a:t>
-            </a:r>
-            <a:endParaRPr lang="en-US" sz="1500" dirty="0"/>
-          </a:p>
-        </p:txBody>
-      </p:sp>
-    </p:spTree>
-  </p:cSld>
-  <p:clrMapOvr>
-    <a:masterClrMapping/>
-  </p:clrMapOvr>
-</p:sld>
-</file>
-
-<file path=ppt/slides/slide7.xml><?xml version="1.0" encoding="utf-8"?>
-<p:sld xmlns:a="http://schemas.openxmlformats.org/drawingml/2006/main" xmlns:r="http://schemas.openxmlformats.org/officeDocument/2006/relationships" xmlns:p="http://schemas.openxmlformats.org/presentationml/2006/main">
   <p:cSld name="Slide 9">
     <p:bg>
       <p:bgPr>
@@ -7753,7 +6034,7 @@
 </p:sld>
 </file>
 
-<file path=ppt/slides/slide8.xml><?xml version="1.0" encoding="utf-8"?>
+<file path=ppt/slides/slide6.xml><?xml version="1.0" encoding="utf-8"?>
 <p:sld xmlns:a="http://schemas.openxmlformats.org/drawingml/2006/main" xmlns:r="http://schemas.openxmlformats.org/officeDocument/2006/relationships" xmlns:p="http://schemas.openxmlformats.org/presentationml/2006/main">
   <p:cSld name="Slide 10">
     <p:bg>
@@ -8285,7 +6566,7 @@
 </p:sld>
 </file>
 
-<file path=ppt/slides/slide9.xml><?xml version="1.0" encoding="utf-8"?>
+<file path=ppt/slides/slide7.xml><?xml version="1.0" encoding="utf-8"?>
 <p:sld xmlns:a="http://schemas.openxmlformats.org/drawingml/2006/main" xmlns:r="http://schemas.openxmlformats.org/officeDocument/2006/relationships" xmlns:p="http://schemas.openxmlformats.org/presentationml/2006/main">
   <p:cSld name="Slide 11">
     <p:bg>
@@ -9078,6 +7359,347 @@
               <a:t>Tiempo de fuente separado del costo de cómputo, con muestras cada 0,2 s.</a:t>
             </a:r>
             <a:endParaRPr lang="en-US" sz="1300" dirty="0"/>
+          </a:p>
+        </p:txBody>
+      </p:sp>
+    </p:spTree>
+  </p:cSld>
+  <p:clrMapOvr>
+    <a:masterClrMapping/>
+  </p:clrMapOvr>
+</p:sld>
+</file>
+
+<file path=ppt/slides/slide8.xml><?xml version="1.0" encoding="utf-8"?>
+<p:sld xmlns:a="http://schemas.openxmlformats.org/drawingml/2006/main" xmlns:r="http://schemas.openxmlformats.org/officeDocument/2006/relationships" xmlns:p="http://schemas.openxmlformats.org/presentationml/2006/main">
+  <p:cSld name="Slide 13">
+    <p:bg>
+      <p:bgPr>
+        <a:solidFill>
+          <a:srgbClr val="0B1F3A"/>
+        </a:solidFill>
+        <a:effectLst/>
+      </p:bgPr>
+    </p:bg>
+    <p:spTree>
+      <p:nvGrpSpPr>
+        <p:cNvPr id="1" name=""/>
+        <p:cNvGrpSpPr/>
+        <p:nvPr/>
+      </p:nvGrpSpPr>
+      <p:grpSpPr>
+        <a:xfrm>
+          <a:off x="0" y="0"/>
+          <a:ext cx="0" cy="0"/>
+          <a:chOff x="0" y="0"/>
+          <a:chExt cx="0" cy="0"/>
+        </a:xfrm>
+      </p:grpSpPr>
+      <p:sp>
+        <p:nvSpPr>
+          <p:cNvPr id="2" name="Text 0"/>
+          <p:cNvSpPr txBox="1"/>
+          <p:nvPr/>
+        </p:nvSpPr>
+        <p:spPr>
+          <a:xfrm>
+            <a:off x="457200" y="320040"/>
+            <a:ext cx="8229600" cy="640080"/>
+          </a:xfrm>
+          <a:prstGeom prst="rect">
+            <a:avLst/>
+          </a:prstGeom>
+          <a:noFill/>
+          <a:ln/>
+        </p:spPr>
+        <p:txBody>
+          <a:bodyPr wrap="square" lIns="0" tIns="0" rIns="0" bIns="0" rtlCol="0" anchor="ctr"/>
+          <a:lstStyle/>
+          <a:p>
+            <a:pPr marL="0" indent="0">
+              <a:buNone/>
+            </a:pPr>
+            <a:r>
+              <a:rPr lang="en-US" sz="2800" b="1" dirty="0">
+                <a:solidFill>
+                  <a:srgbClr val="FFFFFF"/>
+                </a:solidFill>
+                <a:latin typeface="Cambria" pitchFamily="34" charset="0"/>
+                <a:ea typeface="Cambria" pitchFamily="34" charset="-122"/>
+                <a:cs typeface="Cambria" pitchFamily="34" charset="-120"/>
+              </a:rPr>
+              <a:t>Conclusiones y próximos pasos</a:t>
+            </a:r>
+            <a:endParaRPr lang="en-US" sz="2800" dirty="0"/>
+          </a:p>
+        </p:txBody>
+      </p:sp>
+      <p:sp>
+        <p:nvSpPr>
+          <p:cNvPr id="3" name="Text 1"/>
+          <p:cNvSpPr txBox="1"/>
+          <p:nvPr/>
+        </p:nvSpPr>
+        <p:spPr>
+          <a:xfrm>
+            <a:off x="457200" y="1188720"/>
+            <a:ext cx="3840480" cy="365760"/>
+          </a:xfrm>
+          <a:prstGeom prst="rect">
+            <a:avLst/>
+          </a:prstGeom>
+          <a:noFill/>
+          <a:ln/>
+        </p:spPr>
+        <p:txBody>
+          <a:bodyPr wrap="square" lIns="0" tIns="0" rIns="0" bIns="0" rtlCol="0" anchor="t"/>
+          <a:lstStyle/>
+          <a:p>
+            <a:pPr marL="0" indent="0">
+              <a:buNone/>
+            </a:pPr>
+            <a:r>
+              <a:rPr lang="en-US" sz="2000" b="1" dirty="0">
+                <a:solidFill>
+                  <a:srgbClr val="F2A93B"/>
+                </a:solidFill>
+                <a:latin typeface="Cambria" pitchFamily="34" charset="0"/>
+                <a:ea typeface="Cambria" pitchFamily="34" charset="-122"/>
+                <a:cs typeface="Cambria" pitchFamily="34" charset="-120"/>
+              </a:rPr>
+              <a:t>Conclusiones</a:t>
+            </a:r>
+            <a:endParaRPr lang="en-US" sz="2000" dirty="0"/>
+          </a:p>
+        </p:txBody>
+      </p:sp>
+      <p:sp>
+        <p:nvSpPr>
+          <p:cNvPr id="4" name="Text 2"/>
+          <p:cNvSpPr txBox="1"/>
+          <p:nvPr/>
+        </p:nvSpPr>
+        <p:spPr>
+          <a:xfrm>
+            <a:off x="457200" y="1691640"/>
+            <a:ext cx="3840480" cy="2743200"/>
+          </a:xfrm>
+          <a:prstGeom prst="rect">
+            <a:avLst/>
+          </a:prstGeom>
+          <a:noFill/>
+          <a:ln/>
+        </p:spPr>
+        <p:txBody>
+          <a:bodyPr wrap="square" lIns="0" tIns="0" rIns="0" bIns="0" rtlCol="0" anchor="t"/>
+          <a:lstStyle/>
+          <a:p>
+            <a:pPr marL="342900" indent="-342900">
+              <a:spcAft>
+                <a:spcPts val="600"/>
+              </a:spcAft>
+              <a:buSzPct val="100000"/>
+              <a:buChar char="•"/>
+            </a:pPr>
+            <a:r>
+              <a:rPr lang="en-US" sz="1600" dirty="0">
+                <a:solidFill>
+                  <a:srgbClr val="FFFFFF"/>
+                </a:solidFill>
+                <a:latin typeface="Calibri" pitchFamily="34" charset="0"/>
+                <a:ea typeface="Calibri" pitchFamily="34" charset="-122"/>
+                <a:cs typeface="Calibri" pitchFamily="34" charset="-120"/>
+              </a:rPr>
+              <a:t>El sistema ya conecta personas que entran con ventas por hora.</a:t>
+            </a:r>
+            <a:endParaRPr lang="en-US" sz="1600" dirty="0"/>
+          </a:p>
+          <a:p>
+            <a:pPr marL="342900" indent="-342900">
+              <a:spcAft>
+                <a:spcPts val="600"/>
+              </a:spcAft>
+              <a:buSzPct val="100000"/>
+              <a:buChar char="•"/>
+            </a:pPr>
+            <a:r>
+              <a:rPr lang="en-US" sz="1600" dirty="0">
+                <a:solidFill>
+                  <a:srgbClr val="FFFFFF"/>
+                </a:solidFill>
+                <a:latin typeface="Calibri" pitchFamily="34" charset="0"/>
+                <a:ea typeface="Calibri" pitchFamily="34" charset="-122"/>
+                <a:cs typeface="Calibri" pitchFamily="34" charset="-120"/>
+              </a:rPr>
+              <a:t>Proyecta y pronostica con nivel de confianza explícito.</a:t>
+            </a:r>
+            <a:endParaRPr lang="en-US" sz="1600" dirty="0"/>
+          </a:p>
+          <a:p>
+            <a:pPr marL="342900" indent="-342900">
+              <a:spcAft>
+                <a:spcPts val="600"/>
+              </a:spcAft>
+              <a:buSzPct val="100000"/>
+              <a:buChar char="•"/>
+            </a:pPr>
+            <a:r>
+              <a:rPr lang="en-US" sz="1600" dirty="0">
+                <a:solidFill>
+                  <a:srgbClr val="FFFFFF"/>
+                </a:solidFill>
+                <a:latin typeface="Calibri" pitchFamily="34" charset="0"/>
+                <a:ea typeface="Calibri" pitchFamily="34" charset="-122"/>
+                <a:cs typeface="Calibri" pitchFamily="34" charset="-120"/>
+              </a:rPr>
+              <a:t>Declara sus límites: sin causalidad y sin inventar cifras.</a:t>
+            </a:r>
+            <a:endParaRPr lang="en-US" sz="1600" dirty="0"/>
+          </a:p>
+        </p:txBody>
+      </p:sp>
+      <p:sp>
+        <p:nvSpPr>
+          <p:cNvPr id="5" name="Text 3"/>
+          <p:cNvSpPr txBox="1"/>
+          <p:nvPr/>
+        </p:nvSpPr>
+        <p:spPr>
+          <a:xfrm>
+            <a:off x="4754880" y="1188720"/>
+            <a:ext cx="3840480" cy="365760"/>
+          </a:xfrm>
+          <a:prstGeom prst="rect">
+            <a:avLst/>
+          </a:prstGeom>
+          <a:noFill/>
+          <a:ln/>
+        </p:spPr>
+        <p:txBody>
+          <a:bodyPr wrap="square" lIns="0" tIns="0" rIns="0" bIns="0" rtlCol="0" anchor="t"/>
+          <a:lstStyle/>
+          <a:p>
+            <a:pPr marL="0" indent="0">
+              <a:buNone/>
+            </a:pPr>
+            <a:r>
+              <a:rPr lang="en-US" sz="2000" b="1" dirty="0">
+                <a:solidFill>
+                  <a:srgbClr val="F2A93B"/>
+                </a:solidFill>
+                <a:latin typeface="Cambria" pitchFamily="34" charset="0"/>
+                <a:ea typeface="Cambria" pitchFamily="34" charset="-122"/>
+                <a:cs typeface="Cambria" pitchFamily="34" charset="-120"/>
+              </a:rPr>
+              <a:t>Siguiente</a:t>
+            </a:r>
+            <a:endParaRPr lang="en-US" sz="2000" dirty="0"/>
+          </a:p>
+        </p:txBody>
+      </p:sp>
+      <p:sp>
+        <p:nvSpPr>
+          <p:cNvPr id="6" name="Text 4"/>
+          <p:cNvSpPr txBox="1"/>
+          <p:nvPr/>
+        </p:nvSpPr>
+        <p:spPr>
+          <a:xfrm>
+            <a:off x="4754880" y="1691640"/>
+            <a:ext cx="3840480" cy="2743200"/>
+          </a:xfrm>
+          <a:prstGeom prst="rect">
+            <a:avLst/>
+          </a:prstGeom>
+          <a:noFill/>
+          <a:ln/>
+        </p:spPr>
+        <p:txBody>
+          <a:bodyPr wrap="square" lIns="0" tIns="0" rIns="0" bIns="0" rtlCol="0" anchor="t"/>
+          <a:lstStyle/>
+          <a:p>
+            <a:pPr marL="342900" indent="-342900">
+              <a:spcAft>
+                <a:spcPts val="600"/>
+              </a:spcAft>
+              <a:buSzPct val="100000"/>
+              <a:buChar char="•"/>
+            </a:pPr>
+            <a:r>
+              <a:rPr lang="en-US" sz="1600" dirty="0">
+                <a:solidFill>
+                  <a:srgbClr val="FFFFFF"/>
+                </a:solidFill>
+                <a:latin typeface="Calibri" pitchFamily="34" charset="0"/>
+                <a:ea typeface="Calibri" pitchFamily="34" charset="-122"/>
+                <a:cs typeface="Calibri" pitchFamily="34" charset="-120"/>
+              </a:rPr>
+              <a:t>Probar con ventas reales de un local.</a:t>
+            </a:r>
+            <a:endParaRPr lang="en-US" sz="1600" dirty="0"/>
+          </a:p>
+          <a:p>
+            <a:pPr marL="342900" indent="-342900">
+              <a:spcAft>
+                <a:spcPts val="600"/>
+              </a:spcAft>
+              <a:buSzPct val="100000"/>
+              <a:buChar char="•"/>
+            </a:pPr>
+            <a:r>
+              <a:rPr lang="en-US" sz="1600" dirty="0">
+                <a:solidFill>
+                  <a:srgbClr val="FFFFFF"/>
+                </a:solidFill>
+                <a:latin typeface="Calibri" pitchFamily="34" charset="0"/>
+                <a:ea typeface="Calibri" pitchFamily="34" charset="-122"/>
+                <a:cs typeface="Calibri" pitchFamily="34" charset="-120"/>
+              </a:rPr>
+              <a:t>Medir la precisión con videos anotados.</a:t>
+            </a:r>
+            <a:endParaRPr lang="en-US" sz="1600" dirty="0"/>
+          </a:p>
+          <a:p>
+            <a:pPr marL="342900" indent="-342900">
+              <a:spcAft>
+                <a:spcPts val="600"/>
+              </a:spcAft>
+              <a:buSzPct val="100000"/>
+              <a:buChar char="•"/>
+            </a:pPr>
+            <a:r>
+              <a:rPr lang="en-US" sz="1600" dirty="0">
+                <a:solidFill>
+                  <a:srgbClr val="FFFFFF"/>
+                </a:solidFill>
+                <a:latin typeface="Calibri" pitchFamily="34" charset="0"/>
+                <a:ea typeface="Calibri" pitchFamily="34" charset="-122"/>
+                <a:cs typeface="Calibri" pitchFamily="34" charset="-120"/>
+              </a:rPr>
+              <a:t>Solicitar a LAP material del terminal.</a:t>
+            </a:r>
+            <a:endParaRPr lang="en-US" sz="1600" dirty="0"/>
+          </a:p>
+          <a:p>
+            <a:pPr marL="342900" indent="-342900">
+              <a:spcAft>
+                <a:spcPts val="600"/>
+              </a:spcAft>
+              <a:buSzPct val="100000"/>
+              <a:buChar char="•"/>
+            </a:pPr>
+            <a:r>
+              <a:rPr lang="en-US" sz="1600" dirty="0">
+                <a:solidFill>
+                  <a:srgbClr val="FFFFFF"/>
+                </a:solidFill>
+                <a:latin typeface="Calibri" pitchFamily="34" charset="0"/>
+                <a:ea typeface="Calibri" pitchFamily="34" charset="-122"/>
+                <a:cs typeface="Calibri" pitchFamily="34" charset="-120"/>
+              </a:rPr>
+              <a:t>Evaluar GPU para operar casi en tiempo real.</a:t>
+            </a:r>
+            <a:endParaRPr lang="en-US" sz="1600" dirty="0"/>
           </a:p>
         </p:txBody>
       </p:sp>

</xml_diff>